<commit_message>
Add body injury map, stepped pyramid, risk matrix, and bullet gauges
Two new slides in the safety review deck: a human-body injury-location
infographic sized/colored by real Body Part counts, a reimagined stepped
Safety Pyramid, a Risk Rating x Department matrix table, and TRIR/LTIFR
bullet-graph gauges with a days-since-incident hero counter (marked
illustrative since the dataset's dates span past and future relative to
today, so a real streak can't be derived from it yet).

Co-Authored-By: Claude Sonnet 5 <noreply@anthropic.com>
Claude-Session: https://claude.ai/code/session_01LHbyssEhh2Ppeh6FtkfUjf
</commit_message>
<xml_diff>
--- a/dashboard/RCPL_Executive_Leadership_Safety_Review.pptx
+++ b/dashboard/RCPL_Executive_Leadership_Safety_Review.pptx
@@ -12,6 +12,8 @@
     <p:sldId id="260" r:id="rId11"/>
     <p:sldId id="261" r:id="rId12"/>
     <p:sldId id="262" r:id="rId13"/>
+    <p:sldId id="263" r:id="rId14"/>
+    <p:sldId id="264" r:id="rId15"/>
   </p:sldIdLst>
   <p:sldSz cx="12191695" cy="6858000" type="screen4x3"/>
   <p:notesSz cx="6858000" cy="9144000"/>
@@ -916,6 +918,178 @@
     <a:p>
       <a:pPr>
         <a:defRPr sz="800">
+          <a:latin typeface="Segoe UI"/>
+        </a:defRPr>
+      </a:pPr>
+      <a:endParaRPr lang="en-US"/>
+    </a:p>
+  </c:txPr>
+  <c:externalData r:id="rId1">
+    <c:autoUpdate val="0"/>
+  </c:externalData>
+</c:chartSpace>
+</file>
+
+<file path=ppt/charts/chart15.xml><?xml version="1.0" encoding="utf-8"?>
+<c:chartSpace xmlns:c="http://schemas.openxmlformats.org/drawingml/2006/chart" xmlns:a="http://schemas.openxmlformats.org/drawingml/2006/main" xmlns:r="http://schemas.openxmlformats.org/officeDocument/2006/relationships">
+  <c:date1904 val="0"/>
+  <c:chart>
+    <c:title>
+      <c:tx>
+        <c:rich>
+          <a:bodyPr/>
+          <a:lstStyle/>
+          <a:p>
+            <a:pPr>
+              <a:defRPr sz="1300" b="1">
+                <a:solidFill>
+                  <a:srgbClr val="0F3D6E"/>
+                </a:solidFill>
+              </a:defRPr>
+            </a:pPr>
+            <a:r>
+              <a:t>Injuries by Body Part (sorted)</a:t>
+            </a:r>
+          </a:p>
+        </c:rich>
+      </c:tx>
+      <c:layout/>
+      <c:overlay val="0"/>
+    </c:title>
+    <c:autoTitleDeleted val="0"/>
+    <c:plotArea>
+      <c:barChart>
+        <c:barDir val="bar"/>
+        <c:grouping val="clustered"/>
+        <c:ser>
+          <c:idx val="0"/>
+          <c:order val="0"/>
+          <c:tx>
+            <c:strRef>
+              <c:f>Sheet1!$B$1</c:f>
+              <c:strCache>
+                <c:ptCount val="1"/>
+                <c:pt idx="0">
+                  <c:v>Count</c:v>
+                </c:pt>
+              </c:strCache>
+            </c:strRef>
+          </c:tx>
+          <c:spPr>
+            <a:solidFill>
+              <a:srgbClr val="DC2626"/>
+            </a:solidFill>
+            <a:ln>
+              <a:noFill/>
+            </a:ln>
+          </c:spPr>
+          <c:cat>
+            <c:strRef>
+              <c:f>Sheet1!$A$2:$A$9</c:f>
+              <c:strCache>
+                <c:ptCount val="8"/>
+                <c:pt idx="0">
+                  <c:v>Multiple</c:v>
+                </c:pt>
+                <c:pt idx="1">
+                  <c:v>Back</c:v>
+                </c:pt>
+                <c:pt idx="2">
+                  <c:v>Hand/Finger</c:v>
+                </c:pt>
+                <c:pt idx="3">
+                  <c:v>Eye</c:v>
+                </c:pt>
+                <c:pt idx="4">
+                  <c:v>Foot/Leg</c:v>
+                </c:pt>
+                <c:pt idx="5">
+                  <c:v>Head</c:v>
+                </c:pt>
+                <c:pt idx="6">
+                  <c:v>Arm</c:v>
+                </c:pt>
+                <c:pt idx="7">
+                  <c:v>Torso</c:v>
+                </c:pt>
+              </c:strCache>
+            </c:strRef>
+          </c:cat>
+          <c:val>
+            <c:numRef>
+              <c:f>Sheet1!$B$2:$B$9</c:f>
+              <c:numCache>
+                <c:formatCode>General</c:formatCode>
+                <c:ptCount val="8"/>
+                <c:pt idx="0">
+                  <c:v>11</c:v>
+                </c:pt>
+                <c:pt idx="1">
+                  <c:v>8</c:v>
+                </c:pt>
+                <c:pt idx="2">
+                  <c:v>7</c:v>
+                </c:pt>
+                <c:pt idx="3">
+                  <c:v>6</c:v>
+                </c:pt>
+                <c:pt idx="4">
+                  <c:v>6</c:v>
+                </c:pt>
+                <c:pt idx="5">
+                  <c:v>5</c:v>
+                </c:pt>
+                <c:pt idx="6">
+                  <c:v>4</c:v>
+                </c:pt>
+                <c:pt idx="7">
+                  <c:v>1</c:v>
+                </c:pt>
+              </c:numCache>
+            </c:numRef>
+          </c:val>
+        </c:ser>
+        <c:axId val="-2068027336"/>
+        <c:axId val="-2113994440"/>
+      </c:barChart>
+      <c:catAx>
+        <c:axId val="-2068027336"/>
+        <c:scaling>
+          <c:orientation val="minMax"/>
+        </c:scaling>
+        <c:delete val="0"/>
+        <c:axPos val="l"/>
+        <c:majorTickMark val="out"/>
+        <c:minorTickMark val="none"/>
+        <c:tickLblPos val="nextTo"/>
+        <c:crossAx val="-2113994440"/>
+        <c:crosses val="autoZero"/>
+        <c:auto val="1"/>
+        <c:lblAlgn val="ctr"/>
+        <c:lblOffset val="100"/>
+        <c:noMultiLvlLbl val="0"/>
+      </c:catAx>
+      <c:valAx>
+        <c:axId val="-2113994440"/>
+        <c:scaling/>
+        <c:delete val="0"/>
+        <c:axPos val="b"/>
+        <c:majorGridlines/>
+        <c:majorTickMark val="out"/>
+        <c:minorTickMark val="none"/>
+        <c:tickLblPos val="nextTo"/>
+        <c:crossAx val="-2068027336"/>
+        <c:crosses val="autoZero"/>
+      </c:valAx>
+    </c:plotArea>
+    <c:dispBlanksAs val="gap"/>
+  </c:chart>
+  <c:txPr>
+    <a:bodyPr/>
+    <a:lstStyle/>
+    <a:p>
+      <a:pPr>
+        <a:defRPr sz="1000">
           <a:latin typeface="Segoe UI"/>
         </a:defRPr>
       </a:pPr>
@@ -8384,6 +8558,3656 @@
               </a:defRPr>
             </a:pPr>
             <a:r>
+              <a:t>🧍  BODY INJURY MAPPING &amp; SAFETY PYRAMID</a:t>
+            </a:r>
+          </a:p>
+        </p:txBody>
+      </p:sp>
+      <p:sp>
+        <p:nvSpPr>
+          <p:cNvPr id="4" name="TextBox 3"/>
+          <p:cNvSpPr txBox="1"/>
+          <p:nvPr/>
+        </p:nvSpPr>
+        <p:spPr>
+          <a:xfrm>
+            <a:off x="365760" y="566928"/>
+            <a:ext cx="9601200" cy="320040"/>
+          </a:xfrm>
+          <a:prstGeom prst="rect">
+            <a:avLst/>
+          </a:prstGeom>
+          <a:noFill/>
+        </p:spPr>
+        <p:txBody>
+          <a:bodyPr wrap="none">
+            <a:spAutoFit/>
+          </a:bodyPr>
+          <a:lstStyle/>
+          <a:p>
+            <a:pPr>
+              <a:defRPr sz="1100">
+                <a:solidFill>
+                  <a:srgbClr val="CFE0F0"/>
+                </a:solidFill>
+                <a:latin typeface="Segoe UI"/>
+              </a:defRPr>
+            </a:pPr>
+            <a:r>
+              <a:t>Where injuries occur on the body (12-month, real data) — front view</a:t>
+            </a:r>
+          </a:p>
+        </p:txBody>
+      </p:sp>
+      <p:sp>
+        <p:nvSpPr>
+          <p:cNvPr id="5" name="Rectangle 4"/>
+          <p:cNvSpPr/>
+          <p:nvPr/>
+        </p:nvSpPr>
+        <p:spPr>
+          <a:xfrm>
+            <a:off x="10241280" y="137160"/>
+            <a:ext cx="1737360" cy="685800"/>
+          </a:xfrm>
+          <a:prstGeom prst="rect">
+            <a:avLst/>
+          </a:prstGeom>
+          <a:solidFill>
+            <a:srgbClr val="D71920"/>
+          </a:solidFill>
+          <a:ln>
+            <a:noFill/>
+          </a:ln>
+        </p:spPr>
+        <p:style>
+          <a:lnRef idx="1">
+            <a:schemeClr val="accent1"/>
+          </a:lnRef>
+          <a:fillRef idx="3">
+            <a:schemeClr val="accent1"/>
+          </a:fillRef>
+          <a:effectRef idx="2">
+            <a:schemeClr val="accent1"/>
+          </a:effectRef>
+          <a:fontRef idx="minor">
+            <a:schemeClr val="lt1"/>
+          </a:fontRef>
+        </p:style>
+        <p:txBody>
+          <a:bodyPr rtlCol="0" anchor="ctr" wrap="square"/>
+          <a:lstStyle/>
+          <a:p>
+            <a:pPr algn="ctr">
+              <a:defRPr sz="1300" b="1">
+                <a:solidFill>
+                  <a:srgbClr val="FFFFFF"/>
+                </a:solidFill>
+                <a:latin typeface="Segoe UI"/>
+              </a:defRPr>
+            </a:pPr>
+            <a:r>
+              <a:t>RCPL · Campa</a:t>
+            </a:r>
+          </a:p>
+        </p:txBody>
+      </p:sp>
+      <p:sp>
+        <p:nvSpPr>
+          <p:cNvPr id="6" name="Oval 5"/>
+          <p:cNvSpPr/>
+          <p:nvPr/>
+        </p:nvSpPr>
+        <p:spPr>
+          <a:xfrm>
+            <a:off x="1234440" y="1234440"/>
+            <a:ext cx="822960" cy="822960"/>
+          </a:xfrm>
+          <a:prstGeom prst="ellipse">
+            <a:avLst/>
+          </a:prstGeom>
+          <a:solidFill>
+            <a:srgbClr val="CBD5E1"/>
+          </a:solidFill>
+          <a:ln>
+            <a:noFill/>
+          </a:ln>
+        </p:spPr>
+        <p:style>
+          <a:lnRef idx="1">
+            <a:schemeClr val="accent1"/>
+          </a:lnRef>
+          <a:fillRef idx="3">
+            <a:schemeClr val="accent1"/>
+          </a:fillRef>
+          <a:effectRef idx="2">
+            <a:schemeClr val="accent1"/>
+          </a:effectRef>
+          <a:fontRef idx="minor">
+            <a:schemeClr val="lt1"/>
+          </a:fontRef>
+        </p:style>
+        <p:txBody>
+          <a:bodyPr rtlCol="0" anchor="ctr"/>
+          <a:lstStyle/>
+          <a:p>
+            <a:pPr algn="ctr"/>
+          </a:p>
+        </p:txBody>
+      </p:sp>
+      <p:sp>
+        <p:nvSpPr>
+          <p:cNvPr id="7" name="Rectangle 6"/>
+          <p:cNvSpPr/>
+          <p:nvPr/>
+        </p:nvSpPr>
+        <p:spPr>
+          <a:xfrm>
+            <a:off x="1508760" y="2011680"/>
+            <a:ext cx="274320" cy="182880"/>
+          </a:xfrm>
+          <a:prstGeom prst="rect">
+            <a:avLst/>
+          </a:prstGeom>
+          <a:solidFill>
+            <a:srgbClr val="CBD5E1"/>
+          </a:solidFill>
+          <a:ln>
+            <a:noFill/>
+          </a:ln>
+        </p:spPr>
+        <p:style>
+          <a:lnRef idx="1">
+            <a:schemeClr val="accent1"/>
+          </a:lnRef>
+          <a:fillRef idx="3">
+            <a:schemeClr val="accent1"/>
+          </a:fillRef>
+          <a:effectRef idx="2">
+            <a:schemeClr val="accent1"/>
+          </a:effectRef>
+          <a:fontRef idx="minor">
+            <a:schemeClr val="lt1"/>
+          </a:fontRef>
+        </p:style>
+        <p:txBody>
+          <a:bodyPr rtlCol="0" anchor="ctr"/>
+          <a:lstStyle/>
+          <a:p>
+            <a:pPr algn="ctr"/>
+          </a:p>
+        </p:txBody>
+      </p:sp>
+      <p:sp>
+        <p:nvSpPr>
+          <p:cNvPr id="8" name="Rounded Rectangle 7"/>
+          <p:cNvSpPr/>
+          <p:nvPr/>
+        </p:nvSpPr>
+        <p:spPr>
+          <a:xfrm>
+            <a:off x="1005840" y="2148840"/>
+            <a:ext cx="1280160" cy="1737360"/>
+          </a:xfrm>
+          <a:prstGeom prst="roundRect">
+            <a:avLst/>
+          </a:prstGeom>
+          <a:solidFill>
+            <a:srgbClr val="CBD5E1"/>
+          </a:solidFill>
+          <a:ln>
+            <a:noFill/>
+          </a:ln>
+        </p:spPr>
+        <p:style>
+          <a:lnRef idx="1">
+            <a:schemeClr val="accent1"/>
+          </a:lnRef>
+          <a:fillRef idx="3">
+            <a:schemeClr val="accent1"/>
+          </a:fillRef>
+          <a:effectRef idx="2">
+            <a:schemeClr val="accent1"/>
+          </a:effectRef>
+          <a:fontRef idx="minor">
+            <a:schemeClr val="lt1"/>
+          </a:fontRef>
+        </p:style>
+        <p:txBody>
+          <a:bodyPr rtlCol="0" anchor="ctr"/>
+          <a:lstStyle/>
+          <a:p>
+            <a:pPr algn="ctr"/>
+          </a:p>
+        </p:txBody>
+      </p:sp>
+      <p:sp>
+        <p:nvSpPr>
+          <p:cNvPr id="9" name="Rounded Rectangle 8"/>
+          <p:cNvSpPr/>
+          <p:nvPr/>
+        </p:nvSpPr>
+        <p:spPr>
+          <a:xfrm>
+            <a:off x="594360" y="2240280"/>
+            <a:ext cx="365760" cy="1554480"/>
+          </a:xfrm>
+          <a:prstGeom prst="roundRect">
+            <a:avLst/>
+          </a:prstGeom>
+          <a:solidFill>
+            <a:srgbClr val="CBD5E1"/>
+          </a:solidFill>
+          <a:ln>
+            <a:noFill/>
+          </a:ln>
+        </p:spPr>
+        <p:style>
+          <a:lnRef idx="1">
+            <a:schemeClr val="accent1"/>
+          </a:lnRef>
+          <a:fillRef idx="3">
+            <a:schemeClr val="accent1"/>
+          </a:fillRef>
+          <a:effectRef idx="2">
+            <a:schemeClr val="accent1"/>
+          </a:effectRef>
+          <a:fontRef idx="minor">
+            <a:schemeClr val="lt1"/>
+          </a:fontRef>
+        </p:style>
+        <p:txBody>
+          <a:bodyPr rtlCol="0" anchor="ctr"/>
+          <a:lstStyle/>
+          <a:p>
+            <a:pPr algn="ctr"/>
+          </a:p>
+        </p:txBody>
+      </p:sp>
+      <p:sp>
+        <p:nvSpPr>
+          <p:cNvPr id="10" name="Rounded Rectangle 9"/>
+          <p:cNvSpPr/>
+          <p:nvPr/>
+        </p:nvSpPr>
+        <p:spPr>
+          <a:xfrm>
+            <a:off x="2331719" y="2240280"/>
+            <a:ext cx="365760" cy="1554480"/>
+          </a:xfrm>
+          <a:prstGeom prst="roundRect">
+            <a:avLst/>
+          </a:prstGeom>
+          <a:solidFill>
+            <a:srgbClr val="CBD5E1"/>
+          </a:solidFill>
+          <a:ln>
+            <a:noFill/>
+          </a:ln>
+        </p:spPr>
+        <p:style>
+          <a:lnRef idx="1">
+            <a:schemeClr val="accent1"/>
+          </a:lnRef>
+          <a:fillRef idx="3">
+            <a:schemeClr val="accent1"/>
+          </a:fillRef>
+          <a:effectRef idx="2">
+            <a:schemeClr val="accent1"/>
+          </a:effectRef>
+          <a:fontRef idx="minor">
+            <a:schemeClr val="lt1"/>
+          </a:fontRef>
+        </p:style>
+        <p:txBody>
+          <a:bodyPr rtlCol="0" anchor="ctr"/>
+          <a:lstStyle/>
+          <a:p>
+            <a:pPr algn="ctr"/>
+          </a:p>
+        </p:txBody>
+      </p:sp>
+      <p:sp>
+        <p:nvSpPr>
+          <p:cNvPr id="11" name="Oval 10"/>
+          <p:cNvSpPr/>
+          <p:nvPr/>
+        </p:nvSpPr>
+        <p:spPr>
+          <a:xfrm>
+            <a:off x="548640" y="3749040"/>
+            <a:ext cx="457200" cy="457200"/>
+          </a:xfrm>
+          <a:prstGeom prst="ellipse">
+            <a:avLst/>
+          </a:prstGeom>
+          <a:solidFill>
+            <a:srgbClr val="CBD5E1"/>
+          </a:solidFill>
+          <a:ln>
+            <a:noFill/>
+          </a:ln>
+        </p:spPr>
+        <p:style>
+          <a:lnRef idx="1">
+            <a:schemeClr val="accent1"/>
+          </a:lnRef>
+          <a:fillRef idx="3">
+            <a:schemeClr val="accent1"/>
+          </a:fillRef>
+          <a:effectRef idx="2">
+            <a:schemeClr val="accent1"/>
+          </a:effectRef>
+          <a:fontRef idx="minor">
+            <a:schemeClr val="lt1"/>
+          </a:fontRef>
+        </p:style>
+        <p:txBody>
+          <a:bodyPr rtlCol="0" anchor="ctr"/>
+          <a:lstStyle/>
+          <a:p>
+            <a:pPr algn="ctr"/>
+          </a:p>
+        </p:txBody>
+      </p:sp>
+      <p:sp>
+        <p:nvSpPr>
+          <p:cNvPr id="12" name="Oval 11"/>
+          <p:cNvSpPr/>
+          <p:nvPr/>
+        </p:nvSpPr>
+        <p:spPr>
+          <a:xfrm>
+            <a:off x="2286000" y="3749040"/>
+            <a:ext cx="457200" cy="457200"/>
+          </a:xfrm>
+          <a:prstGeom prst="ellipse">
+            <a:avLst/>
+          </a:prstGeom>
+          <a:solidFill>
+            <a:srgbClr val="CBD5E1"/>
+          </a:solidFill>
+          <a:ln>
+            <a:noFill/>
+          </a:ln>
+        </p:spPr>
+        <p:style>
+          <a:lnRef idx="1">
+            <a:schemeClr val="accent1"/>
+          </a:lnRef>
+          <a:fillRef idx="3">
+            <a:schemeClr val="accent1"/>
+          </a:fillRef>
+          <a:effectRef idx="2">
+            <a:schemeClr val="accent1"/>
+          </a:effectRef>
+          <a:fontRef idx="minor">
+            <a:schemeClr val="lt1"/>
+          </a:fontRef>
+        </p:style>
+        <p:txBody>
+          <a:bodyPr rtlCol="0" anchor="ctr"/>
+          <a:lstStyle/>
+          <a:p>
+            <a:pPr algn="ctr"/>
+          </a:p>
+        </p:txBody>
+      </p:sp>
+      <p:sp>
+        <p:nvSpPr>
+          <p:cNvPr id="13" name="Rounded Rectangle 12"/>
+          <p:cNvSpPr/>
+          <p:nvPr/>
+        </p:nvSpPr>
+        <p:spPr>
+          <a:xfrm>
+            <a:off x="1097280" y="3840480"/>
+            <a:ext cx="502920" cy="1828800"/>
+          </a:xfrm>
+          <a:prstGeom prst="roundRect">
+            <a:avLst/>
+          </a:prstGeom>
+          <a:solidFill>
+            <a:srgbClr val="CBD5E1"/>
+          </a:solidFill>
+          <a:ln>
+            <a:noFill/>
+          </a:ln>
+        </p:spPr>
+        <p:style>
+          <a:lnRef idx="1">
+            <a:schemeClr val="accent1"/>
+          </a:lnRef>
+          <a:fillRef idx="3">
+            <a:schemeClr val="accent1"/>
+          </a:fillRef>
+          <a:effectRef idx="2">
+            <a:schemeClr val="accent1"/>
+          </a:effectRef>
+          <a:fontRef idx="minor">
+            <a:schemeClr val="lt1"/>
+          </a:fontRef>
+        </p:style>
+        <p:txBody>
+          <a:bodyPr rtlCol="0" anchor="ctr"/>
+          <a:lstStyle/>
+          <a:p>
+            <a:pPr algn="ctr"/>
+          </a:p>
+        </p:txBody>
+      </p:sp>
+      <p:sp>
+        <p:nvSpPr>
+          <p:cNvPr id="14" name="Rounded Rectangle 13"/>
+          <p:cNvSpPr/>
+          <p:nvPr/>
+        </p:nvSpPr>
+        <p:spPr>
+          <a:xfrm>
+            <a:off x="1691640" y="3840480"/>
+            <a:ext cx="502920" cy="1828800"/>
+          </a:xfrm>
+          <a:prstGeom prst="roundRect">
+            <a:avLst/>
+          </a:prstGeom>
+          <a:solidFill>
+            <a:srgbClr val="CBD5E1"/>
+          </a:solidFill>
+          <a:ln>
+            <a:noFill/>
+          </a:ln>
+        </p:spPr>
+        <p:style>
+          <a:lnRef idx="1">
+            <a:schemeClr val="accent1"/>
+          </a:lnRef>
+          <a:fillRef idx="3">
+            <a:schemeClr val="accent1"/>
+          </a:fillRef>
+          <a:effectRef idx="2">
+            <a:schemeClr val="accent1"/>
+          </a:effectRef>
+          <a:fontRef idx="minor">
+            <a:schemeClr val="lt1"/>
+          </a:fontRef>
+        </p:style>
+        <p:txBody>
+          <a:bodyPr rtlCol="0" anchor="ctr"/>
+          <a:lstStyle/>
+          <a:p>
+            <a:pPr algn="ctr"/>
+          </a:p>
+        </p:txBody>
+      </p:sp>
+      <p:sp>
+        <p:nvSpPr>
+          <p:cNvPr id="15" name="Oval 14"/>
+          <p:cNvSpPr/>
+          <p:nvPr/>
+        </p:nvSpPr>
+        <p:spPr>
+          <a:xfrm>
+            <a:off x="1005840" y="5577840"/>
+            <a:ext cx="502920" cy="320040"/>
+          </a:xfrm>
+          <a:prstGeom prst="ellipse">
+            <a:avLst/>
+          </a:prstGeom>
+          <a:solidFill>
+            <a:srgbClr val="CBD5E1"/>
+          </a:solidFill>
+          <a:ln>
+            <a:noFill/>
+          </a:ln>
+        </p:spPr>
+        <p:style>
+          <a:lnRef idx="1">
+            <a:schemeClr val="accent1"/>
+          </a:lnRef>
+          <a:fillRef idx="3">
+            <a:schemeClr val="accent1"/>
+          </a:fillRef>
+          <a:effectRef idx="2">
+            <a:schemeClr val="accent1"/>
+          </a:effectRef>
+          <a:fontRef idx="minor">
+            <a:schemeClr val="lt1"/>
+          </a:fontRef>
+        </p:style>
+        <p:txBody>
+          <a:bodyPr rtlCol="0" anchor="ctr"/>
+          <a:lstStyle/>
+          <a:p>
+            <a:pPr algn="ctr"/>
+          </a:p>
+        </p:txBody>
+      </p:sp>
+      <p:sp>
+        <p:nvSpPr>
+          <p:cNvPr id="16" name="Oval 15"/>
+          <p:cNvSpPr/>
+          <p:nvPr/>
+        </p:nvSpPr>
+        <p:spPr>
+          <a:xfrm>
+            <a:off x="1783080" y="5577840"/>
+            <a:ext cx="502920" cy="320040"/>
+          </a:xfrm>
+          <a:prstGeom prst="ellipse">
+            <a:avLst/>
+          </a:prstGeom>
+          <a:solidFill>
+            <a:srgbClr val="CBD5E1"/>
+          </a:solidFill>
+          <a:ln>
+            <a:noFill/>
+          </a:ln>
+        </p:spPr>
+        <p:style>
+          <a:lnRef idx="1">
+            <a:schemeClr val="accent1"/>
+          </a:lnRef>
+          <a:fillRef idx="3">
+            <a:schemeClr val="accent1"/>
+          </a:fillRef>
+          <a:effectRef idx="2">
+            <a:schemeClr val="accent1"/>
+          </a:effectRef>
+          <a:fontRef idx="minor">
+            <a:schemeClr val="lt1"/>
+          </a:fontRef>
+        </p:style>
+        <p:txBody>
+          <a:bodyPr rtlCol="0" anchor="ctr"/>
+          <a:lstStyle/>
+          <a:p>
+            <a:pPr algn="ctr"/>
+          </a:p>
+        </p:txBody>
+      </p:sp>
+      <p:sp>
+        <p:nvSpPr>
+          <p:cNvPr id="17" name="Oval 16"/>
+          <p:cNvSpPr/>
+          <p:nvPr/>
+        </p:nvSpPr>
+        <p:spPr>
+          <a:xfrm>
+            <a:off x="1408176" y="1408176"/>
+            <a:ext cx="475488" cy="475488"/>
+          </a:xfrm>
+          <a:prstGeom prst="ellipse">
+            <a:avLst/>
+          </a:prstGeom>
+          <a:solidFill>
+            <a:srgbClr val="DC2626"/>
+          </a:solidFill>
+          <a:ln w="19050">
+            <a:solidFill>
+              <a:srgbClr val="FFFFFF"/>
+            </a:solidFill>
+          </a:ln>
+        </p:spPr>
+        <p:style>
+          <a:lnRef idx="1">
+            <a:schemeClr val="accent1"/>
+          </a:lnRef>
+          <a:fillRef idx="3">
+            <a:schemeClr val="accent1"/>
+          </a:fillRef>
+          <a:effectRef idx="2">
+            <a:schemeClr val="accent1"/>
+          </a:effectRef>
+          <a:fontRef idx="minor">
+            <a:schemeClr val="lt1"/>
+          </a:fontRef>
+        </p:style>
+        <p:txBody>
+          <a:bodyPr rtlCol="0" anchor="ctr" wrap="none"/>
+          <a:lstStyle/>
+          <a:p>
+            <a:pPr algn="ctr">
+              <a:defRPr sz="1300" b="1">
+                <a:solidFill>
+                  <a:srgbClr val="FFFFFF"/>
+                </a:solidFill>
+                <a:latin typeface="Segoe UI"/>
+              </a:defRPr>
+            </a:pPr>
+            <a:r>
+              <a:t>5</a:t>
+            </a:r>
+          </a:p>
+        </p:txBody>
+      </p:sp>
+      <p:sp>
+        <p:nvSpPr>
+          <p:cNvPr id="18" name="TextBox 17"/>
+          <p:cNvSpPr txBox="1"/>
+          <p:nvPr/>
+        </p:nvSpPr>
+        <p:spPr>
+          <a:xfrm>
+            <a:off x="1133856" y="1901952"/>
+            <a:ext cx="1298448" cy="201168"/>
+          </a:xfrm>
+          <a:prstGeom prst="rect">
+            <a:avLst/>
+          </a:prstGeom>
+          <a:noFill/>
+        </p:spPr>
+        <p:txBody>
+          <a:bodyPr wrap="none">
+            <a:spAutoFit/>
+          </a:bodyPr>
+          <a:lstStyle/>
+          <a:p>
+            <a:pPr algn="ctr">
+              <a:defRPr sz="800" b="1">
+                <a:solidFill>
+                  <a:srgbClr val="334155"/>
+                </a:solidFill>
+                <a:latin typeface="Segoe UI"/>
+              </a:defRPr>
+            </a:pPr>
+            <a:r>
+              <a:t>Head</a:t>
+            </a:r>
+          </a:p>
+        </p:txBody>
+      </p:sp>
+      <p:sp>
+        <p:nvSpPr>
+          <p:cNvPr id="19" name="Oval 18"/>
+          <p:cNvSpPr/>
+          <p:nvPr/>
+        </p:nvSpPr>
+        <p:spPr>
+          <a:xfrm>
+            <a:off x="1806854" y="1121054"/>
+            <a:ext cx="501091" cy="501091"/>
+          </a:xfrm>
+          <a:prstGeom prst="ellipse">
+            <a:avLst/>
+          </a:prstGeom>
+          <a:solidFill>
+            <a:srgbClr val="EA580C"/>
+          </a:solidFill>
+          <a:ln w="19050">
+            <a:solidFill>
+              <a:srgbClr val="FFFFFF"/>
+            </a:solidFill>
+          </a:ln>
+        </p:spPr>
+        <p:style>
+          <a:lnRef idx="1">
+            <a:schemeClr val="accent1"/>
+          </a:lnRef>
+          <a:fillRef idx="3">
+            <a:schemeClr val="accent1"/>
+          </a:fillRef>
+          <a:effectRef idx="2">
+            <a:schemeClr val="accent1"/>
+          </a:effectRef>
+          <a:fontRef idx="minor">
+            <a:schemeClr val="lt1"/>
+          </a:fontRef>
+        </p:style>
+        <p:txBody>
+          <a:bodyPr rtlCol="0" anchor="ctr" wrap="none"/>
+          <a:lstStyle/>
+          <a:p>
+            <a:pPr algn="ctr">
+              <a:defRPr sz="1300" b="1">
+                <a:solidFill>
+                  <a:srgbClr val="FFFFFF"/>
+                </a:solidFill>
+                <a:latin typeface="Segoe UI"/>
+              </a:defRPr>
+            </a:pPr>
+            <a:r>
+              <a:t>6</a:t>
+            </a:r>
+          </a:p>
+        </p:txBody>
+      </p:sp>
+      <p:sp>
+        <p:nvSpPr>
+          <p:cNvPr id="20" name="TextBox 19"/>
+          <p:cNvSpPr txBox="1"/>
+          <p:nvPr/>
+        </p:nvSpPr>
+        <p:spPr>
+          <a:xfrm>
+            <a:off x="1532534" y="1640433"/>
+            <a:ext cx="1324051" cy="201168"/>
+          </a:xfrm>
+          <a:prstGeom prst="rect">
+            <a:avLst/>
+          </a:prstGeom>
+          <a:noFill/>
+        </p:spPr>
+        <p:txBody>
+          <a:bodyPr wrap="none">
+            <a:spAutoFit/>
+          </a:bodyPr>
+          <a:lstStyle/>
+          <a:p>
+            <a:pPr algn="ctr">
+              <a:defRPr sz="800" b="1">
+                <a:solidFill>
+                  <a:srgbClr val="334155"/>
+                </a:solidFill>
+                <a:latin typeface="Segoe UI"/>
+              </a:defRPr>
+            </a:pPr>
+            <a:r>
+              <a:t>Eye</a:t>
+            </a:r>
+          </a:p>
+        </p:txBody>
+      </p:sp>
+      <p:sp>
+        <p:nvSpPr>
+          <p:cNvPr id="21" name="Oval 20"/>
+          <p:cNvSpPr/>
+          <p:nvPr/>
+        </p:nvSpPr>
+        <p:spPr>
+          <a:xfrm>
+            <a:off x="1459382" y="2785262"/>
+            <a:ext cx="373075" cy="373075"/>
+          </a:xfrm>
+          <a:prstGeom prst="ellipse">
+            <a:avLst/>
+          </a:prstGeom>
+          <a:solidFill>
+            <a:srgbClr val="F59E0B"/>
+          </a:solidFill>
+          <a:ln w="19050">
+            <a:solidFill>
+              <a:srgbClr val="FFFFFF"/>
+            </a:solidFill>
+          </a:ln>
+        </p:spPr>
+        <p:style>
+          <a:lnRef idx="1">
+            <a:schemeClr val="accent1"/>
+          </a:lnRef>
+          <a:fillRef idx="3">
+            <a:schemeClr val="accent1"/>
+          </a:fillRef>
+          <a:effectRef idx="2">
+            <a:schemeClr val="accent1"/>
+          </a:effectRef>
+          <a:fontRef idx="minor">
+            <a:schemeClr val="lt1"/>
+          </a:fontRef>
+        </p:style>
+        <p:txBody>
+          <a:bodyPr rtlCol="0" anchor="ctr" wrap="none"/>
+          <a:lstStyle/>
+          <a:p>
+            <a:pPr algn="ctr">
+              <a:defRPr sz="1300" b="1">
+                <a:solidFill>
+                  <a:srgbClr val="FFFFFF"/>
+                </a:solidFill>
+                <a:latin typeface="Segoe UI"/>
+              </a:defRPr>
+            </a:pPr>
+            <a:r>
+              <a:t>1</a:t>
+            </a:r>
+          </a:p>
+        </p:txBody>
+      </p:sp>
+      <p:sp>
+        <p:nvSpPr>
+          <p:cNvPr id="22" name="TextBox 21"/>
+          <p:cNvSpPr txBox="1"/>
+          <p:nvPr/>
+        </p:nvSpPr>
+        <p:spPr>
+          <a:xfrm>
+            <a:off x="1185062" y="3176625"/>
+            <a:ext cx="1196035" cy="201168"/>
+          </a:xfrm>
+          <a:prstGeom prst="rect">
+            <a:avLst/>
+          </a:prstGeom>
+          <a:noFill/>
+        </p:spPr>
+        <p:txBody>
+          <a:bodyPr wrap="none">
+            <a:spAutoFit/>
+          </a:bodyPr>
+          <a:lstStyle/>
+          <a:p>
+            <a:pPr algn="ctr">
+              <a:defRPr sz="800" b="1">
+                <a:solidFill>
+                  <a:srgbClr val="334155"/>
+                </a:solidFill>
+                <a:latin typeface="Segoe UI"/>
+              </a:defRPr>
+            </a:pPr>
+            <a:r>
+              <a:t>Torso/Chest</a:t>
+            </a:r>
+          </a:p>
+        </p:txBody>
+      </p:sp>
+      <p:sp>
+        <p:nvSpPr>
+          <p:cNvPr id="23" name="Oval 22"/>
+          <p:cNvSpPr/>
+          <p:nvPr/>
+        </p:nvSpPr>
+        <p:spPr>
+          <a:xfrm>
+            <a:off x="1369771" y="3244291"/>
+            <a:ext cx="552297" cy="552297"/>
+          </a:xfrm>
+          <a:prstGeom prst="ellipse">
+            <a:avLst/>
+          </a:prstGeom>
+          <a:solidFill>
+            <a:srgbClr val="7C3AED"/>
+          </a:solidFill>
+          <a:ln w="19050">
+            <a:solidFill>
+              <a:srgbClr val="FFFFFF"/>
+            </a:solidFill>
+          </a:ln>
+        </p:spPr>
+        <p:style>
+          <a:lnRef idx="1">
+            <a:schemeClr val="accent1"/>
+          </a:lnRef>
+          <a:fillRef idx="3">
+            <a:schemeClr val="accent1"/>
+          </a:fillRef>
+          <a:effectRef idx="2">
+            <a:schemeClr val="accent1"/>
+          </a:effectRef>
+          <a:fontRef idx="minor">
+            <a:schemeClr val="lt1"/>
+          </a:fontRef>
+        </p:style>
+        <p:txBody>
+          <a:bodyPr rtlCol="0" anchor="ctr" wrap="none"/>
+          <a:lstStyle/>
+          <a:p>
+            <a:pPr algn="ctr">
+              <a:defRPr sz="1300" b="1">
+                <a:solidFill>
+                  <a:srgbClr val="FFFFFF"/>
+                </a:solidFill>
+                <a:latin typeface="Segoe UI"/>
+              </a:defRPr>
+            </a:pPr>
+            <a:r>
+              <a:t>8</a:t>
+            </a:r>
+          </a:p>
+        </p:txBody>
+      </p:sp>
+      <p:sp>
+        <p:nvSpPr>
+          <p:cNvPr id="24" name="TextBox 23"/>
+          <p:cNvSpPr txBox="1"/>
+          <p:nvPr/>
+        </p:nvSpPr>
+        <p:spPr>
+          <a:xfrm>
+            <a:off x="1095451" y="3814876"/>
+            <a:ext cx="1375257" cy="201168"/>
+          </a:xfrm>
+          <a:prstGeom prst="rect">
+            <a:avLst/>
+          </a:prstGeom>
+          <a:noFill/>
+        </p:spPr>
+        <p:txBody>
+          <a:bodyPr wrap="none">
+            <a:spAutoFit/>
+          </a:bodyPr>
+          <a:lstStyle/>
+          <a:p>
+            <a:pPr algn="ctr">
+              <a:defRPr sz="800" b="1">
+                <a:solidFill>
+                  <a:srgbClr val="334155"/>
+                </a:solidFill>
+                <a:latin typeface="Segoe UI"/>
+              </a:defRPr>
+            </a:pPr>
+            <a:r>
+              <a:t>Back (rear)</a:t>
+            </a:r>
+          </a:p>
+        </p:txBody>
+      </p:sp>
+      <p:sp>
+        <p:nvSpPr>
+          <p:cNvPr id="25" name="Oval 24"/>
+          <p:cNvSpPr/>
+          <p:nvPr/>
+        </p:nvSpPr>
+        <p:spPr>
+          <a:xfrm>
+            <a:off x="2289658" y="2792578"/>
+            <a:ext cx="449884" cy="449884"/>
+          </a:xfrm>
+          <a:prstGeom prst="ellipse">
+            <a:avLst/>
+          </a:prstGeom>
+          <a:solidFill>
+            <a:srgbClr val="0B6EA8"/>
+          </a:solidFill>
+          <a:ln w="19050">
+            <a:solidFill>
+              <a:srgbClr val="FFFFFF"/>
+            </a:solidFill>
+          </a:ln>
+        </p:spPr>
+        <p:style>
+          <a:lnRef idx="1">
+            <a:schemeClr val="accent1"/>
+          </a:lnRef>
+          <a:fillRef idx="3">
+            <a:schemeClr val="accent1"/>
+          </a:fillRef>
+          <a:effectRef idx="2">
+            <a:schemeClr val="accent1"/>
+          </a:effectRef>
+          <a:fontRef idx="minor">
+            <a:schemeClr val="lt1"/>
+          </a:fontRef>
+        </p:style>
+        <p:txBody>
+          <a:bodyPr rtlCol="0" anchor="ctr" wrap="none"/>
+          <a:lstStyle/>
+          <a:p>
+            <a:pPr algn="ctr">
+              <a:defRPr sz="1300" b="1">
+                <a:solidFill>
+                  <a:srgbClr val="FFFFFF"/>
+                </a:solidFill>
+                <a:latin typeface="Segoe UI"/>
+              </a:defRPr>
+            </a:pPr>
+            <a:r>
+              <a:t>4</a:t>
+            </a:r>
+          </a:p>
+        </p:txBody>
+      </p:sp>
+      <p:sp>
+        <p:nvSpPr>
+          <p:cNvPr id="26" name="TextBox 25"/>
+          <p:cNvSpPr txBox="1"/>
+          <p:nvPr/>
+        </p:nvSpPr>
+        <p:spPr>
+          <a:xfrm>
+            <a:off x="2015338" y="3260750"/>
+            <a:ext cx="1272844" cy="201168"/>
+          </a:xfrm>
+          <a:prstGeom prst="rect">
+            <a:avLst/>
+          </a:prstGeom>
+          <a:noFill/>
+        </p:spPr>
+        <p:txBody>
+          <a:bodyPr wrap="none">
+            <a:spAutoFit/>
+          </a:bodyPr>
+          <a:lstStyle/>
+          <a:p>
+            <a:pPr algn="ctr">
+              <a:defRPr sz="800" b="1">
+                <a:solidFill>
+                  <a:srgbClr val="334155"/>
+                </a:solidFill>
+                <a:latin typeface="Segoe UI"/>
+              </a:defRPr>
+            </a:pPr>
+            <a:r>
+              <a:t>Arm</a:t>
+            </a:r>
+          </a:p>
+        </p:txBody>
+      </p:sp>
+      <p:sp>
+        <p:nvSpPr>
+          <p:cNvPr id="27" name="Oval 26"/>
+          <p:cNvSpPr/>
+          <p:nvPr/>
+        </p:nvSpPr>
+        <p:spPr>
+          <a:xfrm>
+            <a:off x="2251253" y="3714293"/>
+            <a:ext cx="526694" cy="526694"/>
+          </a:xfrm>
+          <a:prstGeom prst="ellipse">
+            <a:avLst/>
+          </a:prstGeom>
+          <a:solidFill>
+            <a:srgbClr val="D71920"/>
+          </a:solidFill>
+          <a:ln w="19050">
+            <a:solidFill>
+              <a:srgbClr val="FFFFFF"/>
+            </a:solidFill>
+          </a:ln>
+        </p:spPr>
+        <p:style>
+          <a:lnRef idx="1">
+            <a:schemeClr val="accent1"/>
+          </a:lnRef>
+          <a:fillRef idx="3">
+            <a:schemeClr val="accent1"/>
+          </a:fillRef>
+          <a:effectRef idx="2">
+            <a:schemeClr val="accent1"/>
+          </a:effectRef>
+          <a:fontRef idx="minor">
+            <a:schemeClr val="lt1"/>
+          </a:fontRef>
+        </p:style>
+        <p:txBody>
+          <a:bodyPr rtlCol="0" anchor="ctr" wrap="none"/>
+          <a:lstStyle/>
+          <a:p>
+            <a:pPr algn="ctr">
+              <a:defRPr sz="1300" b="1">
+                <a:solidFill>
+                  <a:srgbClr val="FFFFFF"/>
+                </a:solidFill>
+                <a:latin typeface="Segoe UI"/>
+              </a:defRPr>
+            </a:pPr>
+            <a:r>
+              <a:t>7</a:t>
+            </a:r>
+          </a:p>
+        </p:txBody>
+      </p:sp>
+      <p:sp>
+        <p:nvSpPr>
+          <p:cNvPr id="28" name="TextBox 27"/>
+          <p:cNvSpPr txBox="1"/>
+          <p:nvPr/>
+        </p:nvSpPr>
+        <p:spPr>
+          <a:xfrm>
+            <a:off x="1976933" y="4259275"/>
+            <a:ext cx="1349654" cy="201168"/>
+          </a:xfrm>
+          <a:prstGeom prst="rect">
+            <a:avLst/>
+          </a:prstGeom>
+          <a:noFill/>
+        </p:spPr>
+        <p:txBody>
+          <a:bodyPr wrap="none">
+            <a:spAutoFit/>
+          </a:bodyPr>
+          <a:lstStyle/>
+          <a:p>
+            <a:pPr algn="ctr">
+              <a:defRPr sz="800" b="1">
+                <a:solidFill>
+                  <a:srgbClr val="334155"/>
+                </a:solidFill>
+                <a:latin typeface="Segoe UI"/>
+              </a:defRPr>
+            </a:pPr>
+            <a:r>
+              <a:t>Hand/Finger</a:t>
+            </a:r>
+          </a:p>
+        </p:txBody>
+      </p:sp>
+      <p:sp>
+        <p:nvSpPr>
+          <p:cNvPr id="29" name="Oval 28"/>
+          <p:cNvSpPr/>
+          <p:nvPr/>
+        </p:nvSpPr>
+        <p:spPr>
+          <a:xfrm>
+            <a:off x="1669694" y="4550054"/>
+            <a:ext cx="501091" cy="501091"/>
+          </a:xfrm>
+          <a:prstGeom prst="ellipse">
+            <a:avLst/>
+          </a:prstGeom>
+          <a:solidFill>
+            <a:srgbClr val="334155"/>
+          </a:solidFill>
+          <a:ln w="19050">
+            <a:solidFill>
+              <a:srgbClr val="FFFFFF"/>
+            </a:solidFill>
+          </a:ln>
+        </p:spPr>
+        <p:style>
+          <a:lnRef idx="1">
+            <a:schemeClr val="accent1"/>
+          </a:lnRef>
+          <a:fillRef idx="3">
+            <a:schemeClr val="accent1"/>
+          </a:fillRef>
+          <a:effectRef idx="2">
+            <a:schemeClr val="accent1"/>
+          </a:effectRef>
+          <a:fontRef idx="minor">
+            <a:schemeClr val="lt1"/>
+          </a:fontRef>
+        </p:style>
+        <p:txBody>
+          <a:bodyPr rtlCol="0" anchor="ctr" wrap="none"/>
+          <a:lstStyle/>
+          <a:p>
+            <a:pPr algn="ctr">
+              <a:defRPr sz="1300" b="1">
+                <a:solidFill>
+                  <a:srgbClr val="FFFFFF"/>
+                </a:solidFill>
+                <a:latin typeface="Segoe UI"/>
+              </a:defRPr>
+            </a:pPr>
+            <a:r>
+              <a:t>6</a:t>
+            </a:r>
+          </a:p>
+        </p:txBody>
+      </p:sp>
+      <p:sp>
+        <p:nvSpPr>
+          <p:cNvPr id="30" name="TextBox 29"/>
+          <p:cNvSpPr txBox="1"/>
+          <p:nvPr/>
+        </p:nvSpPr>
+        <p:spPr>
+          <a:xfrm>
+            <a:off x="1395374" y="5069433"/>
+            <a:ext cx="1324051" cy="201168"/>
+          </a:xfrm>
+          <a:prstGeom prst="rect">
+            <a:avLst/>
+          </a:prstGeom>
+          <a:noFill/>
+        </p:spPr>
+        <p:txBody>
+          <a:bodyPr wrap="none">
+            <a:spAutoFit/>
+          </a:bodyPr>
+          <a:lstStyle/>
+          <a:p>
+            <a:pPr algn="ctr">
+              <a:defRPr sz="800" b="1">
+                <a:solidFill>
+                  <a:srgbClr val="334155"/>
+                </a:solidFill>
+                <a:latin typeface="Segoe UI"/>
+              </a:defRPr>
+            </a:pPr>
+            <a:r>
+              <a:t>Foot/Leg</a:t>
+            </a:r>
+          </a:p>
+        </p:txBody>
+      </p:sp>
+      <p:sp>
+        <p:nvSpPr>
+          <p:cNvPr id="31" name="Rectangle 30"/>
+          <p:cNvSpPr/>
+          <p:nvPr/>
+        </p:nvSpPr>
+        <p:spPr>
+          <a:xfrm>
+            <a:off x="320040" y="5989320"/>
+            <a:ext cx="3931920" cy="685800"/>
+          </a:xfrm>
+          <a:prstGeom prst="rect">
+            <a:avLst/>
+          </a:prstGeom>
+          <a:solidFill>
+            <a:srgbClr val="F1F5F9"/>
+          </a:solidFill>
+          <a:ln w="9525">
+            <a:solidFill>
+              <a:srgbClr val="E2E8EF"/>
+            </a:solidFill>
+          </a:ln>
+        </p:spPr>
+        <p:style>
+          <a:lnRef idx="1">
+            <a:schemeClr val="accent1"/>
+          </a:lnRef>
+          <a:fillRef idx="3">
+            <a:schemeClr val="accent1"/>
+          </a:fillRef>
+          <a:effectRef idx="2">
+            <a:schemeClr val="accent1"/>
+          </a:effectRef>
+          <a:fontRef idx="minor">
+            <a:schemeClr val="lt1"/>
+          </a:fontRef>
+        </p:style>
+        <p:txBody>
+          <a:bodyPr rtlCol="0" anchor="ctr" wrap="square" lIns="127000" tIns="76200" rIns="127000"/>
+          <a:lstStyle/>
+          <a:p>
+            <a:pPr algn="ctr">
+              <a:defRPr sz="900">
+                <a:solidFill>
+                  <a:srgbClr val="334155"/>
+                </a:solidFill>
+                <a:latin typeface="Segoe UI"/>
+              </a:defRPr>
+            </a:pPr>
+            <a:r>
+              <a:t>"Multiple": 11 incidents involved more than one body region (shown separately, cannot be pinned to a single marker) — these are typically the most serious cases and warrant priority root-cause review.</a:t>
+            </a:r>
+          </a:p>
+        </p:txBody>
+      </p:sp>
+      <p:graphicFrame>
+        <p:nvGraphicFramePr>
+          <p:cNvPr id="32" name="Chart 31"/>
+          <p:cNvGraphicFramePr>
+            <a:graphicFrameLocks noGrp="1"/>
+          </p:cNvGraphicFramePr>
+          <p:nvPr/>
+        </p:nvGraphicFramePr>
+        <p:xfrm>
+          <a:off x="4160520" y="1234440"/>
+          <a:ext cx="3520440" cy="2743200"/>
+        </p:xfrm>
+        <a:graphic>
+          <a:graphicData uri="http://schemas.openxmlformats.org/drawingml/2006/chart">
+            <c:chart xmlns:c="http://schemas.openxmlformats.org/drawingml/2006/chart" r:id="rId2"/>
+          </a:graphicData>
+        </a:graphic>
+      </p:graphicFrame>
+      <p:sp>
+        <p:nvSpPr>
+          <p:cNvPr id="33" name="Rectangle 32"/>
+          <p:cNvSpPr/>
+          <p:nvPr/>
+        </p:nvSpPr>
+        <p:spPr>
+          <a:xfrm>
+            <a:off x="4160520" y="4160520"/>
+            <a:ext cx="3520440" cy="1737360"/>
+          </a:xfrm>
+          <a:prstGeom prst="rect">
+            <a:avLst/>
+          </a:prstGeom>
+          <a:solidFill>
+            <a:srgbClr val="F1F5F9"/>
+          </a:solidFill>
+          <a:ln w="9525">
+            <a:solidFill>
+              <a:srgbClr val="E2E8EF"/>
+            </a:solidFill>
+          </a:ln>
+        </p:spPr>
+        <p:style>
+          <a:lnRef idx="1">
+            <a:schemeClr val="accent1"/>
+          </a:lnRef>
+          <a:fillRef idx="3">
+            <a:schemeClr val="accent1"/>
+          </a:fillRef>
+          <a:effectRef idx="2">
+            <a:schemeClr val="accent1"/>
+          </a:effectRef>
+          <a:fontRef idx="minor">
+            <a:schemeClr val="lt1"/>
+          </a:fontRef>
+        </p:style>
+        <p:txBody>
+          <a:bodyPr rtlCol="0" anchor="ctr" wrap="square" lIns="127000" tIns="76200" rIns="127000"/>
+          <a:lstStyle/>
+          <a:p>
+            <a:pPr algn="ctr">
+              <a:defRPr sz="950">
+                <a:solidFill>
+                  <a:srgbClr val="334155"/>
+                </a:solidFill>
+                <a:latin typeface="Segoe UI"/>
+              </a:defRPr>
+            </a:pPr>
+            <a:r>
+              <a:t>Reading this: markers are sized by count — the bigger the circle, the more injuries recorded at that location. Back and Hand/Finger are this period's priority zones for targeted PPE/ergonomics review.</a:t>
+            </a:r>
+          </a:p>
+        </p:txBody>
+      </p:sp>
+      <p:sp>
+        <p:nvSpPr>
+          <p:cNvPr id="34" name="Rectangle 33"/>
+          <p:cNvSpPr/>
+          <p:nvPr/>
+        </p:nvSpPr>
+        <p:spPr>
+          <a:xfrm>
+            <a:off x="9593579" y="1234440"/>
+            <a:ext cx="655320" cy="800100"/>
+          </a:xfrm>
+          <a:prstGeom prst="rect">
+            <a:avLst/>
+          </a:prstGeom>
+          <a:solidFill>
+            <a:srgbClr val="DC2626"/>
+          </a:solidFill>
+          <a:ln w="19050">
+            <a:solidFill>
+              <a:srgbClr val="FFFFFF"/>
+            </a:solidFill>
+          </a:ln>
+        </p:spPr>
+        <p:style>
+          <a:lnRef idx="1">
+            <a:schemeClr val="accent1"/>
+          </a:lnRef>
+          <a:fillRef idx="3">
+            <a:schemeClr val="accent1"/>
+          </a:fillRef>
+          <a:effectRef idx="2">
+            <a:schemeClr val="accent1"/>
+          </a:effectRef>
+          <a:fontRef idx="minor">
+            <a:schemeClr val="lt1"/>
+          </a:fontRef>
+        </p:style>
+        <p:txBody>
+          <a:bodyPr rtlCol="0" anchor="ctr" wrap="square"/>
+          <a:lstStyle/>
+          <a:p>
+            <a:pPr algn="ctr">
+              <a:defRPr sz="1100" b="1">
+                <a:solidFill>
+                  <a:srgbClr val="FFFFFF"/>
+                </a:solidFill>
+                <a:latin typeface="Segoe UI"/>
+              </a:defRPr>
+            </a:pPr>
+            <a:r>
+              <a:t>Fatality — 1 (2%)</a:t>
+            </a:r>
+          </a:p>
+        </p:txBody>
+      </p:sp>
+      <p:sp>
+        <p:nvSpPr>
+          <p:cNvPr id="35" name="Rectangle 34"/>
+          <p:cNvSpPr/>
+          <p:nvPr/>
+        </p:nvSpPr>
+        <p:spPr>
+          <a:xfrm>
+            <a:off x="9265919" y="2072640"/>
+            <a:ext cx="1310640" cy="800100"/>
+          </a:xfrm>
+          <a:prstGeom prst="rect">
+            <a:avLst/>
+          </a:prstGeom>
+          <a:solidFill>
+            <a:srgbClr val="B91C1C"/>
+          </a:solidFill>
+          <a:ln w="19050">
+            <a:solidFill>
+              <a:srgbClr val="FFFFFF"/>
+            </a:solidFill>
+          </a:ln>
+        </p:spPr>
+        <p:style>
+          <a:lnRef idx="1">
+            <a:schemeClr val="accent1"/>
+          </a:lnRef>
+          <a:fillRef idx="3">
+            <a:schemeClr val="accent1"/>
+          </a:fillRef>
+          <a:effectRef idx="2">
+            <a:schemeClr val="accent1"/>
+          </a:effectRef>
+          <a:fontRef idx="minor">
+            <a:schemeClr val="lt1"/>
+          </a:fontRef>
+        </p:style>
+        <p:txBody>
+          <a:bodyPr rtlCol="0" anchor="ctr" wrap="square"/>
+          <a:lstStyle/>
+          <a:p>
+            <a:pPr algn="ctr">
+              <a:defRPr sz="1100" b="1">
+                <a:solidFill>
+                  <a:srgbClr val="FFFFFF"/>
+                </a:solidFill>
+                <a:latin typeface="Segoe UI"/>
+              </a:defRPr>
+            </a:pPr>
+            <a:r>
+              <a:t>Lost Time Injury — 0 (0%)</a:t>
+            </a:r>
+          </a:p>
+        </p:txBody>
+      </p:sp>
+      <p:sp>
+        <p:nvSpPr>
+          <p:cNvPr id="36" name="Rectangle 35"/>
+          <p:cNvSpPr/>
+          <p:nvPr/>
+        </p:nvSpPr>
+        <p:spPr>
+          <a:xfrm>
+            <a:off x="8938259" y="2910840"/>
+            <a:ext cx="1965960" cy="800100"/>
+          </a:xfrm>
+          <a:prstGeom prst="rect">
+            <a:avLst/>
+          </a:prstGeom>
+          <a:solidFill>
+            <a:srgbClr val="EA580C"/>
+          </a:solidFill>
+          <a:ln w="19050">
+            <a:solidFill>
+              <a:srgbClr val="FFFFFF"/>
+            </a:solidFill>
+          </a:ln>
+        </p:spPr>
+        <p:style>
+          <a:lnRef idx="1">
+            <a:schemeClr val="accent1"/>
+          </a:lnRef>
+          <a:fillRef idx="3">
+            <a:schemeClr val="accent1"/>
+          </a:fillRef>
+          <a:effectRef idx="2">
+            <a:schemeClr val="accent1"/>
+          </a:effectRef>
+          <a:fontRef idx="minor">
+            <a:schemeClr val="lt1"/>
+          </a:fontRef>
+        </p:style>
+        <p:txBody>
+          <a:bodyPr rtlCol="0" anchor="ctr" wrap="square"/>
+          <a:lstStyle/>
+          <a:p>
+            <a:pPr algn="ctr">
+              <a:defRPr sz="1100" b="1">
+                <a:solidFill>
+                  <a:srgbClr val="FFFFFF"/>
+                </a:solidFill>
+                <a:latin typeface="Segoe UI"/>
+              </a:defRPr>
+            </a:pPr>
+            <a:r>
+              <a:t>Restricted Work — 5 (10%)</a:t>
+            </a:r>
+          </a:p>
+        </p:txBody>
+      </p:sp>
+      <p:sp>
+        <p:nvSpPr>
+          <p:cNvPr id="37" name="Rectangle 36"/>
+          <p:cNvSpPr/>
+          <p:nvPr/>
+        </p:nvSpPr>
+        <p:spPr>
+          <a:xfrm>
+            <a:off x="8610599" y="3749040"/>
+            <a:ext cx="2621280" cy="800100"/>
+          </a:xfrm>
+          <a:prstGeom prst="rect">
+            <a:avLst/>
+          </a:prstGeom>
+          <a:solidFill>
+            <a:srgbClr val="F59E0B"/>
+          </a:solidFill>
+          <a:ln w="19050">
+            <a:solidFill>
+              <a:srgbClr val="FFFFFF"/>
+            </a:solidFill>
+          </a:ln>
+        </p:spPr>
+        <p:style>
+          <a:lnRef idx="1">
+            <a:schemeClr val="accent1"/>
+          </a:lnRef>
+          <a:fillRef idx="3">
+            <a:schemeClr val="accent1"/>
+          </a:fillRef>
+          <a:effectRef idx="2">
+            <a:schemeClr val="accent1"/>
+          </a:effectRef>
+          <a:fontRef idx="minor">
+            <a:schemeClr val="lt1"/>
+          </a:fontRef>
+        </p:style>
+        <p:txBody>
+          <a:bodyPr rtlCol="0" anchor="ctr" wrap="square"/>
+          <a:lstStyle/>
+          <a:p>
+            <a:pPr algn="ctr">
+              <a:defRPr sz="1100" b="1">
+                <a:solidFill>
+                  <a:srgbClr val="FFFFFF"/>
+                </a:solidFill>
+                <a:latin typeface="Segoe UI"/>
+              </a:defRPr>
+            </a:pPr>
+            <a:r>
+              <a:t>Medical Treatment — 5 (10%)</a:t>
+            </a:r>
+          </a:p>
+        </p:txBody>
+      </p:sp>
+      <p:sp>
+        <p:nvSpPr>
+          <p:cNvPr id="38" name="Rectangle 37"/>
+          <p:cNvSpPr/>
+          <p:nvPr/>
+        </p:nvSpPr>
+        <p:spPr>
+          <a:xfrm>
+            <a:off x="8282939" y="4587240"/>
+            <a:ext cx="3276600" cy="800100"/>
+          </a:xfrm>
+          <a:prstGeom prst="rect">
+            <a:avLst/>
+          </a:prstGeom>
+          <a:solidFill>
+            <a:srgbClr val="FDE047"/>
+          </a:solidFill>
+          <a:ln w="19050">
+            <a:solidFill>
+              <a:srgbClr val="FFFFFF"/>
+            </a:solidFill>
+          </a:ln>
+        </p:spPr>
+        <p:style>
+          <a:lnRef idx="1">
+            <a:schemeClr val="accent1"/>
+          </a:lnRef>
+          <a:fillRef idx="3">
+            <a:schemeClr val="accent1"/>
+          </a:fillRef>
+          <a:effectRef idx="2">
+            <a:schemeClr val="accent1"/>
+          </a:effectRef>
+          <a:fontRef idx="minor">
+            <a:schemeClr val="lt1"/>
+          </a:fontRef>
+        </p:style>
+        <p:txBody>
+          <a:bodyPr rtlCol="0" anchor="ctr" wrap="square"/>
+          <a:lstStyle/>
+          <a:p>
+            <a:pPr algn="ctr">
+              <a:defRPr sz="1100" b="1">
+                <a:solidFill>
+                  <a:srgbClr val="FFFFFF"/>
+                </a:solidFill>
+                <a:latin typeface="Segoe UI"/>
+              </a:defRPr>
+            </a:pPr>
+            <a:r>
+              <a:t>First Aid — 7 (15%)</a:t>
+            </a:r>
+          </a:p>
+        </p:txBody>
+      </p:sp>
+      <p:sp>
+        <p:nvSpPr>
+          <p:cNvPr id="39" name="Rectangle 38"/>
+          <p:cNvSpPr/>
+          <p:nvPr/>
+        </p:nvSpPr>
+        <p:spPr>
+          <a:xfrm>
+            <a:off x="7955279" y="5425440"/>
+            <a:ext cx="3931920" cy="800100"/>
+          </a:xfrm>
+          <a:prstGeom prst="rect">
+            <a:avLst/>
+          </a:prstGeom>
+          <a:solidFill>
+            <a:srgbClr val="15A34A"/>
+          </a:solidFill>
+          <a:ln w="19050">
+            <a:solidFill>
+              <a:srgbClr val="FFFFFF"/>
+            </a:solidFill>
+          </a:ln>
+        </p:spPr>
+        <p:style>
+          <a:lnRef idx="1">
+            <a:schemeClr val="accent1"/>
+          </a:lnRef>
+          <a:fillRef idx="3">
+            <a:schemeClr val="accent1"/>
+          </a:fillRef>
+          <a:effectRef idx="2">
+            <a:schemeClr val="accent1"/>
+          </a:effectRef>
+          <a:fontRef idx="minor">
+            <a:schemeClr val="lt1"/>
+          </a:fontRef>
+        </p:style>
+        <p:txBody>
+          <a:bodyPr rtlCol="0" anchor="ctr" wrap="square"/>
+          <a:lstStyle/>
+          <a:p>
+            <a:pPr algn="ctr">
+              <a:defRPr sz="1100" b="1">
+                <a:solidFill>
+                  <a:srgbClr val="FFFFFF"/>
+                </a:solidFill>
+                <a:latin typeface="Segoe UI"/>
+              </a:defRPr>
+            </a:pPr>
+            <a:r>
+              <a:t>Near Miss — 30 (62%)</a:t>
+            </a:r>
+          </a:p>
+        </p:txBody>
+      </p:sp>
+    </p:spTree>
+  </p:cSld>
+  <p:clrMapOvr>
+    <a:masterClrMapping/>
+  </p:clrMapOvr>
+</p:sld>
+</file>
+
+<file path=ppt/slides/slide7.xml><?xml version="1.0" encoding="utf-8"?>
+<p:sld xmlns:a="http://schemas.openxmlformats.org/drawingml/2006/main" xmlns:p="http://schemas.openxmlformats.org/presentationml/2006/main" xmlns:r="http://schemas.openxmlformats.org/officeDocument/2006/relationships">
+  <p:cSld>
+    <p:spTree>
+      <p:nvGrpSpPr>
+        <p:cNvPr id="1" name=""/>
+        <p:cNvGrpSpPr/>
+        <p:nvPr/>
+      </p:nvGrpSpPr>
+      <p:grpSpPr/>
+      <p:sp>
+        <p:nvSpPr>
+          <p:cNvPr id="2" name="Rectangle 1"/>
+          <p:cNvSpPr/>
+          <p:nvPr/>
+        </p:nvSpPr>
+        <p:spPr>
+          <a:xfrm>
+            <a:off x="0" y="0"/>
+            <a:ext cx="12191695" cy="960120"/>
+          </a:xfrm>
+          <a:prstGeom prst="rect">
+            <a:avLst/>
+          </a:prstGeom>
+          <a:solidFill>
+            <a:srgbClr val="0F3D6E"/>
+          </a:solidFill>
+          <a:ln>
+            <a:noFill/>
+          </a:ln>
+        </p:spPr>
+        <p:style>
+          <a:lnRef idx="1">
+            <a:schemeClr val="accent1"/>
+          </a:lnRef>
+          <a:fillRef idx="3">
+            <a:schemeClr val="accent1"/>
+          </a:fillRef>
+          <a:effectRef idx="2">
+            <a:schemeClr val="accent1"/>
+          </a:effectRef>
+          <a:fontRef idx="minor">
+            <a:schemeClr val="lt1"/>
+          </a:fontRef>
+        </p:style>
+        <p:txBody>
+          <a:bodyPr rtlCol="0" anchor="ctr"/>
+          <a:lstStyle/>
+          <a:p>
+            <a:pPr algn="ctr"/>
+          </a:p>
+        </p:txBody>
+      </p:sp>
+      <p:sp>
+        <p:nvSpPr>
+          <p:cNvPr id="3" name="TextBox 2"/>
+          <p:cNvSpPr txBox="1"/>
+          <p:nvPr/>
+        </p:nvSpPr>
+        <p:spPr>
+          <a:xfrm>
+            <a:off x="365760" y="109728"/>
+            <a:ext cx="9601200" cy="548640"/>
+          </a:xfrm>
+          <a:prstGeom prst="rect">
+            <a:avLst/>
+          </a:prstGeom>
+          <a:noFill/>
+        </p:spPr>
+        <p:txBody>
+          <a:bodyPr wrap="none">
+            <a:spAutoFit/>
+          </a:bodyPr>
+          <a:lstStyle/>
+          <a:p>
+            <a:pPr>
+              <a:defRPr sz="2600" b="1">
+                <a:solidFill>
+                  <a:srgbClr val="FFFFFF"/>
+                </a:solidFill>
+                <a:latin typeface="Segoe UI"/>
+              </a:defRPr>
+            </a:pPr>
+            <a:r>
+              <a:t>⏱  RISK MATRIX, INJURY-RATE GAUGES &amp; DAYS-SINCE-INCIDENT</a:t>
+            </a:r>
+          </a:p>
+        </p:txBody>
+      </p:sp>
+      <p:sp>
+        <p:nvSpPr>
+          <p:cNvPr id="4" name="TextBox 3"/>
+          <p:cNvSpPr txBox="1"/>
+          <p:nvPr/>
+        </p:nvSpPr>
+        <p:spPr>
+          <a:xfrm>
+            <a:off x="365760" y="566928"/>
+            <a:ext cx="9601200" cy="320040"/>
+          </a:xfrm>
+          <a:prstGeom prst="rect">
+            <a:avLst/>
+          </a:prstGeom>
+          <a:noFill/>
+        </p:spPr>
+        <p:txBody>
+          <a:bodyPr wrap="none">
+            <a:spAutoFit/>
+          </a:bodyPr>
+          <a:lstStyle/>
+          <a:p>
+            <a:pPr>
+              <a:defRPr sz="1100">
+                <a:solidFill>
+                  <a:srgbClr val="CFE0F0"/>
+                </a:solidFill>
+                <a:latin typeface="Segoe UI"/>
+              </a:defRPr>
+            </a:pPr>
+            <a:r>
+              <a:t>Risk matrix from real data; days-since-incident is an illustrative sample counter</a:t>
+            </a:r>
+          </a:p>
+        </p:txBody>
+      </p:sp>
+      <p:sp>
+        <p:nvSpPr>
+          <p:cNvPr id="5" name="Rectangle 4"/>
+          <p:cNvSpPr/>
+          <p:nvPr/>
+        </p:nvSpPr>
+        <p:spPr>
+          <a:xfrm>
+            <a:off x="10241280" y="137160"/>
+            <a:ext cx="1737360" cy="685800"/>
+          </a:xfrm>
+          <a:prstGeom prst="rect">
+            <a:avLst/>
+          </a:prstGeom>
+          <a:solidFill>
+            <a:srgbClr val="D71920"/>
+          </a:solidFill>
+          <a:ln>
+            <a:noFill/>
+          </a:ln>
+        </p:spPr>
+        <p:style>
+          <a:lnRef idx="1">
+            <a:schemeClr val="accent1"/>
+          </a:lnRef>
+          <a:fillRef idx="3">
+            <a:schemeClr val="accent1"/>
+          </a:fillRef>
+          <a:effectRef idx="2">
+            <a:schemeClr val="accent1"/>
+          </a:effectRef>
+          <a:fontRef idx="minor">
+            <a:schemeClr val="lt1"/>
+          </a:fontRef>
+        </p:style>
+        <p:txBody>
+          <a:bodyPr rtlCol="0" anchor="ctr" wrap="square"/>
+          <a:lstStyle/>
+          <a:p>
+            <a:pPr algn="ctr">
+              <a:defRPr sz="1300" b="1">
+                <a:solidFill>
+                  <a:srgbClr val="FFFFFF"/>
+                </a:solidFill>
+                <a:latin typeface="Segoe UI"/>
+              </a:defRPr>
+            </a:pPr>
+            <a:r>
+              <a:t>RCPL · Campa</a:t>
+            </a:r>
+          </a:p>
+        </p:txBody>
+      </p:sp>
+      <p:sp>
+        <p:nvSpPr>
+          <p:cNvPr id="6" name="Rounded Rectangle 5"/>
+          <p:cNvSpPr/>
+          <p:nvPr/>
+        </p:nvSpPr>
+        <p:spPr>
+          <a:xfrm>
+            <a:off x="457200" y="1234440"/>
+            <a:ext cx="3383280" cy="2194560"/>
+          </a:xfrm>
+          <a:prstGeom prst="roundRect">
+            <a:avLst/>
+          </a:prstGeom>
+          <a:solidFill>
+            <a:srgbClr val="15A34A"/>
+          </a:solidFill>
+          <a:ln>
+            <a:noFill/>
+          </a:ln>
+        </p:spPr>
+        <p:style>
+          <a:lnRef idx="1">
+            <a:schemeClr val="accent1"/>
+          </a:lnRef>
+          <a:fillRef idx="3">
+            <a:schemeClr val="accent1"/>
+          </a:fillRef>
+          <a:effectRef idx="2">
+            <a:schemeClr val="accent1"/>
+          </a:effectRef>
+          <a:fontRef idx="minor">
+            <a:schemeClr val="lt1"/>
+          </a:fontRef>
+        </p:style>
+        <p:txBody>
+          <a:bodyPr rtlCol="0" anchor="ctr" wrap="square"/>
+          <a:lstStyle/>
+          <a:p>
+            <a:pPr algn="ctr">
+              <a:defRPr sz="6400" b="1">
+                <a:solidFill>
+                  <a:srgbClr val="FFFFFF"/>
+                </a:solidFill>
+                <a:latin typeface="Segoe UI"/>
+              </a:defRPr>
+            </a:pPr>
+            <a:r>
+              <a:t>47</a:t>
+            </a:r>
+          </a:p>
+          <a:p>
+            <a:pPr algn="ctr">
+              <a:defRPr sz="1300">
+                <a:solidFill>
+                  <a:srgbClr val="FFFFFF"/>
+                </a:solidFill>
+                <a:latin typeface="Segoe UI"/>
+              </a:defRPr>
+            </a:pPr>
+            <a:r>
+              <a:t>DAYS SINCE LAST LOST-TIME INCIDENT  (illustrative)</a:t>
+            </a:r>
+          </a:p>
+        </p:txBody>
+      </p:sp>
+      <p:sp>
+        <p:nvSpPr>
+          <p:cNvPr id="7" name="TextBox 6"/>
+          <p:cNvSpPr txBox="1"/>
+          <p:nvPr/>
+        </p:nvSpPr>
+        <p:spPr>
+          <a:xfrm>
+            <a:off x="4160520" y="1417320"/>
+            <a:ext cx="3566160" cy="274320"/>
+          </a:xfrm>
+          <a:prstGeom prst="rect">
+            <a:avLst/>
+          </a:prstGeom>
+          <a:noFill/>
+        </p:spPr>
+        <p:txBody>
+          <a:bodyPr wrap="none">
+            <a:spAutoFit/>
+          </a:bodyPr>
+          <a:lstStyle/>
+          <a:p>
+            <a:pPr>
+              <a:defRPr sz="1300" b="1">
+                <a:solidFill>
+                  <a:srgbClr val="334155"/>
+                </a:solidFill>
+                <a:latin typeface="Segoe UI"/>
+              </a:defRPr>
+            </a:pPr>
+            <a:r>
+              <a:t>TRIR</a:t>
+            </a:r>
+          </a:p>
+        </p:txBody>
+      </p:sp>
+      <p:sp>
+        <p:nvSpPr>
+          <p:cNvPr id="8" name="Rectangle 7"/>
+          <p:cNvSpPr/>
+          <p:nvPr/>
+        </p:nvSpPr>
+        <p:spPr>
+          <a:xfrm>
+            <a:off x="4160520" y="1764792"/>
+            <a:ext cx="1188720" cy="457200"/>
+          </a:xfrm>
+          <a:prstGeom prst="rect">
+            <a:avLst/>
+          </a:prstGeom>
+          <a:solidFill>
+            <a:srgbClr val="15A34A"/>
+          </a:solidFill>
+          <a:ln>
+            <a:noFill/>
+          </a:ln>
+        </p:spPr>
+        <p:style>
+          <a:lnRef idx="1">
+            <a:schemeClr val="accent1"/>
+          </a:lnRef>
+          <a:fillRef idx="3">
+            <a:schemeClr val="accent1"/>
+          </a:fillRef>
+          <a:effectRef idx="2">
+            <a:schemeClr val="accent1"/>
+          </a:effectRef>
+          <a:fontRef idx="minor">
+            <a:schemeClr val="lt1"/>
+          </a:fontRef>
+        </p:style>
+        <p:txBody>
+          <a:bodyPr rtlCol="0" anchor="ctr"/>
+          <a:lstStyle/>
+          <a:p>
+            <a:pPr algn="ctr"/>
+          </a:p>
+        </p:txBody>
+      </p:sp>
+      <p:sp>
+        <p:nvSpPr>
+          <p:cNvPr id="9" name="Rectangle 8"/>
+          <p:cNvSpPr/>
+          <p:nvPr/>
+        </p:nvSpPr>
+        <p:spPr>
+          <a:xfrm>
+            <a:off x="5349240" y="1764792"/>
+            <a:ext cx="594360" cy="457200"/>
+          </a:xfrm>
+          <a:prstGeom prst="rect">
+            <a:avLst/>
+          </a:prstGeom>
+          <a:solidFill>
+            <a:srgbClr val="F59E0B"/>
+          </a:solidFill>
+          <a:ln>
+            <a:noFill/>
+          </a:ln>
+        </p:spPr>
+        <p:style>
+          <a:lnRef idx="1">
+            <a:schemeClr val="accent1"/>
+          </a:lnRef>
+          <a:fillRef idx="3">
+            <a:schemeClr val="accent1"/>
+          </a:fillRef>
+          <a:effectRef idx="2">
+            <a:schemeClr val="accent1"/>
+          </a:effectRef>
+          <a:fontRef idx="minor">
+            <a:schemeClr val="lt1"/>
+          </a:fontRef>
+        </p:style>
+        <p:txBody>
+          <a:bodyPr rtlCol="0" anchor="ctr"/>
+          <a:lstStyle/>
+          <a:p>
+            <a:pPr algn="ctr"/>
+          </a:p>
+        </p:txBody>
+      </p:sp>
+      <p:sp>
+        <p:nvSpPr>
+          <p:cNvPr id="10" name="Rectangle 9"/>
+          <p:cNvSpPr/>
+          <p:nvPr/>
+        </p:nvSpPr>
+        <p:spPr>
+          <a:xfrm>
+            <a:off x="5943600" y="1764792"/>
+            <a:ext cx="1783080" cy="457200"/>
+          </a:xfrm>
+          <a:prstGeom prst="rect">
+            <a:avLst/>
+          </a:prstGeom>
+          <a:solidFill>
+            <a:srgbClr val="DC2626"/>
+          </a:solidFill>
+          <a:ln>
+            <a:noFill/>
+          </a:ln>
+        </p:spPr>
+        <p:style>
+          <a:lnRef idx="1">
+            <a:schemeClr val="accent1"/>
+          </a:lnRef>
+          <a:fillRef idx="3">
+            <a:schemeClr val="accent1"/>
+          </a:fillRef>
+          <a:effectRef idx="2">
+            <a:schemeClr val="accent1"/>
+          </a:effectRef>
+          <a:fontRef idx="minor">
+            <a:schemeClr val="lt1"/>
+          </a:fontRef>
+        </p:style>
+        <p:txBody>
+          <a:bodyPr rtlCol="0" anchor="ctr"/>
+          <a:lstStyle/>
+          <a:p>
+            <a:pPr algn="ctr"/>
+          </a:p>
+        </p:txBody>
+      </p:sp>
+      <p:sp>
+        <p:nvSpPr>
+          <p:cNvPr id="11" name="Rectangle 10"/>
+          <p:cNvSpPr/>
+          <p:nvPr/>
+        </p:nvSpPr>
+        <p:spPr>
+          <a:xfrm>
+            <a:off x="4160520" y="1764792"/>
+            <a:ext cx="3566160" cy="457200"/>
+          </a:xfrm>
+          <a:prstGeom prst="rect">
+            <a:avLst/>
+          </a:prstGeom>
+          <a:noFill/>
+          <a:ln w="12700">
+            <a:solidFill>
+              <a:srgbClr val="334155"/>
+            </a:solidFill>
+          </a:ln>
+        </p:spPr>
+        <p:style>
+          <a:lnRef idx="1">
+            <a:schemeClr val="accent1"/>
+          </a:lnRef>
+          <a:fillRef idx="3">
+            <a:schemeClr val="accent1"/>
+          </a:fillRef>
+          <a:effectRef idx="2">
+            <a:schemeClr val="accent1"/>
+          </a:effectRef>
+          <a:fontRef idx="minor">
+            <a:schemeClr val="lt1"/>
+          </a:fontRef>
+        </p:style>
+        <p:txBody>
+          <a:bodyPr rtlCol="0" anchor="ctr"/>
+          <a:lstStyle/>
+          <a:p>
+            <a:pPr algn="ctr"/>
+          </a:p>
+        </p:txBody>
+      </p:sp>
+      <p:sp>
+        <p:nvSpPr>
+          <p:cNvPr id="12" name="Isosceles Triangle 11"/>
+          <p:cNvSpPr/>
+          <p:nvPr/>
+        </p:nvSpPr>
+        <p:spPr>
+          <a:xfrm rot="10800000">
+            <a:off x="6693408" y="1618488"/>
+            <a:ext cx="164592" cy="146304"/>
+          </a:xfrm>
+          <a:prstGeom prst="triangle">
+            <a:avLst/>
+          </a:prstGeom>
+          <a:solidFill>
+            <a:srgbClr val="334155"/>
+          </a:solidFill>
+          <a:ln>
+            <a:noFill/>
+          </a:ln>
+        </p:spPr>
+        <p:style>
+          <a:lnRef idx="1">
+            <a:schemeClr val="accent1"/>
+          </a:lnRef>
+          <a:fillRef idx="3">
+            <a:schemeClr val="accent1"/>
+          </a:fillRef>
+          <a:effectRef idx="2">
+            <a:schemeClr val="accent1"/>
+          </a:effectRef>
+          <a:fontRef idx="minor">
+            <a:schemeClr val="lt1"/>
+          </a:fontRef>
+        </p:style>
+        <p:txBody>
+          <a:bodyPr rtlCol="0" anchor="ctr"/>
+          <a:lstStyle/>
+          <a:p>
+            <a:pPr algn="ctr"/>
+          </a:p>
+        </p:txBody>
+      </p:sp>
+      <p:sp>
+        <p:nvSpPr>
+          <p:cNvPr id="13" name="TextBox 12"/>
+          <p:cNvSpPr txBox="1"/>
+          <p:nvPr/>
+        </p:nvSpPr>
+        <p:spPr>
+          <a:xfrm>
+            <a:off x="4160520" y="2276856"/>
+            <a:ext cx="3566160" cy="365760"/>
+          </a:xfrm>
+          <a:prstGeom prst="rect">
+            <a:avLst/>
+          </a:prstGeom>
+          <a:noFill/>
+        </p:spPr>
+        <p:txBody>
+          <a:bodyPr wrap="none">
+            <a:spAutoFit/>
+          </a:bodyPr>
+          <a:lstStyle/>
+          <a:p>
+            <a:pPr algn="ctr">
+              <a:defRPr sz="1800" b="1">
+                <a:solidFill>
+                  <a:srgbClr val="0F3D6E"/>
+                </a:solidFill>
+                <a:latin typeface="Segoe UI"/>
+              </a:defRPr>
+            </a:pPr>
+            <a:r>
+              <a:t>2.20 </a:t>
+            </a:r>
+          </a:p>
+        </p:txBody>
+      </p:sp>
+      <p:sp>
+        <p:nvSpPr>
+          <p:cNvPr id="14" name="TextBox 13"/>
+          <p:cNvSpPr txBox="1"/>
+          <p:nvPr/>
+        </p:nvSpPr>
+        <p:spPr>
+          <a:xfrm>
+            <a:off x="8092440" y="1417320"/>
+            <a:ext cx="3566160" cy="274320"/>
+          </a:xfrm>
+          <a:prstGeom prst="rect">
+            <a:avLst/>
+          </a:prstGeom>
+          <a:noFill/>
+        </p:spPr>
+        <p:txBody>
+          <a:bodyPr wrap="none">
+            <a:spAutoFit/>
+          </a:bodyPr>
+          <a:lstStyle/>
+          <a:p>
+            <a:pPr>
+              <a:defRPr sz="1300" b="1">
+                <a:solidFill>
+                  <a:srgbClr val="334155"/>
+                </a:solidFill>
+                <a:latin typeface="Segoe UI"/>
+              </a:defRPr>
+            </a:pPr>
+            <a:r>
+              <a:t>LTIFR</a:t>
+            </a:r>
+          </a:p>
+        </p:txBody>
+      </p:sp>
+      <p:sp>
+        <p:nvSpPr>
+          <p:cNvPr id="15" name="Rectangle 14"/>
+          <p:cNvSpPr/>
+          <p:nvPr/>
+        </p:nvSpPr>
+        <p:spPr>
+          <a:xfrm>
+            <a:off x="8092440" y="1764792"/>
+            <a:ext cx="1783080" cy="457200"/>
+          </a:xfrm>
+          <a:prstGeom prst="rect">
+            <a:avLst/>
+          </a:prstGeom>
+          <a:solidFill>
+            <a:srgbClr val="15A34A"/>
+          </a:solidFill>
+          <a:ln>
+            <a:noFill/>
+          </a:ln>
+        </p:spPr>
+        <p:style>
+          <a:lnRef idx="1">
+            <a:schemeClr val="accent1"/>
+          </a:lnRef>
+          <a:fillRef idx="3">
+            <a:schemeClr val="accent1"/>
+          </a:fillRef>
+          <a:effectRef idx="2">
+            <a:schemeClr val="accent1"/>
+          </a:effectRef>
+          <a:fontRef idx="minor">
+            <a:schemeClr val="lt1"/>
+          </a:fontRef>
+        </p:style>
+        <p:txBody>
+          <a:bodyPr rtlCol="0" anchor="ctr"/>
+          <a:lstStyle/>
+          <a:p>
+            <a:pPr algn="ctr"/>
+          </a:p>
+        </p:txBody>
+      </p:sp>
+      <p:sp>
+        <p:nvSpPr>
+          <p:cNvPr id="16" name="Rectangle 15"/>
+          <p:cNvSpPr/>
+          <p:nvPr/>
+        </p:nvSpPr>
+        <p:spPr>
+          <a:xfrm>
+            <a:off x="9875520" y="1764792"/>
+            <a:ext cx="891540" cy="457200"/>
+          </a:xfrm>
+          <a:prstGeom prst="rect">
+            <a:avLst/>
+          </a:prstGeom>
+          <a:solidFill>
+            <a:srgbClr val="F59E0B"/>
+          </a:solidFill>
+          <a:ln>
+            <a:noFill/>
+          </a:ln>
+        </p:spPr>
+        <p:style>
+          <a:lnRef idx="1">
+            <a:schemeClr val="accent1"/>
+          </a:lnRef>
+          <a:fillRef idx="3">
+            <a:schemeClr val="accent1"/>
+          </a:fillRef>
+          <a:effectRef idx="2">
+            <a:schemeClr val="accent1"/>
+          </a:effectRef>
+          <a:fontRef idx="minor">
+            <a:schemeClr val="lt1"/>
+          </a:fontRef>
+        </p:style>
+        <p:txBody>
+          <a:bodyPr rtlCol="0" anchor="ctr"/>
+          <a:lstStyle/>
+          <a:p>
+            <a:pPr algn="ctr"/>
+          </a:p>
+        </p:txBody>
+      </p:sp>
+      <p:sp>
+        <p:nvSpPr>
+          <p:cNvPr id="17" name="Rectangle 16"/>
+          <p:cNvSpPr/>
+          <p:nvPr/>
+        </p:nvSpPr>
+        <p:spPr>
+          <a:xfrm>
+            <a:off x="10767060" y="1764792"/>
+            <a:ext cx="891540" cy="457200"/>
+          </a:xfrm>
+          <a:prstGeom prst="rect">
+            <a:avLst/>
+          </a:prstGeom>
+          <a:solidFill>
+            <a:srgbClr val="DC2626"/>
+          </a:solidFill>
+          <a:ln>
+            <a:noFill/>
+          </a:ln>
+        </p:spPr>
+        <p:style>
+          <a:lnRef idx="1">
+            <a:schemeClr val="accent1"/>
+          </a:lnRef>
+          <a:fillRef idx="3">
+            <a:schemeClr val="accent1"/>
+          </a:fillRef>
+          <a:effectRef idx="2">
+            <a:schemeClr val="accent1"/>
+          </a:effectRef>
+          <a:fontRef idx="minor">
+            <a:schemeClr val="lt1"/>
+          </a:fontRef>
+        </p:style>
+        <p:txBody>
+          <a:bodyPr rtlCol="0" anchor="ctr"/>
+          <a:lstStyle/>
+          <a:p>
+            <a:pPr algn="ctr"/>
+          </a:p>
+        </p:txBody>
+      </p:sp>
+      <p:sp>
+        <p:nvSpPr>
+          <p:cNvPr id="18" name="Rectangle 17"/>
+          <p:cNvSpPr/>
+          <p:nvPr/>
+        </p:nvSpPr>
+        <p:spPr>
+          <a:xfrm>
+            <a:off x="8092440" y="1764792"/>
+            <a:ext cx="3566160" cy="457200"/>
+          </a:xfrm>
+          <a:prstGeom prst="rect">
+            <a:avLst/>
+          </a:prstGeom>
+          <a:noFill/>
+          <a:ln w="12700">
+            <a:solidFill>
+              <a:srgbClr val="334155"/>
+            </a:solidFill>
+          </a:ln>
+        </p:spPr>
+        <p:style>
+          <a:lnRef idx="1">
+            <a:schemeClr val="accent1"/>
+          </a:lnRef>
+          <a:fillRef idx="3">
+            <a:schemeClr val="accent1"/>
+          </a:fillRef>
+          <a:effectRef idx="2">
+            <a:schemeClr val="accent1"/>
+          </a:effectRef>
+          <a:fontRef idx="minor">
+            <a:schemeClr val="lt1"/>
+          </a:fontRef>
+        </p:style>
+        <p:txBody>
+          <a:bodyPr rtlCol="0" anchor="ctr"/>
+          <a:lstStyle/>
+          <a:p>
+            <a:pPr algn="ctr"/>
+          </a:p>
+        </p:txBody>
+      </p:sp>
+      <p:sp>
+        <p:nvSpPr>
+          <p:cNvPr id="19" name="Isosceles Triangle 18"/>
+          <p:cNvSpPr/>
+          <p:nvPr/>
+        </p:nvSpPr>
+        <p:spPr>
+          <a:xfrm rot="10800000">
+            <a:off x="8901684" y="1618488"/>
+            <a:ext cx="164592" cy="146304"/>
+          </a:xfrm>
+          <a:prstGeom prst="triangle">
+            <a:avLst/>
+          </a:prstGeom>
+          <a:solidFill>
+            <a:srgbClr val="334155"/>
+          </a:solidFill>
+          <a:ln>
+            <a:noFill/>
+          </a:ln>
+        </p:spPr>
+        <p:style>
+          <a:lnRef idx="1">
+            <a:schemeClr val="accent1"/>
+          </a:lnRef>
+          <a:fillRef idx="3">
+            <a:schemeClr val="accent1"/>
+          </a:fillRef>
+          <a:effectRef idx="2">
+            <a:schemeClr val="accent1"/>
+          </a:effectRef>
+          <a:fontRef idx="minor">
+            <a:schemeClr val="lt1"/>
+          </a:fontRef>
+        </p:style>
+        <p:txBody>
+          <a:bodyPr rtlCol="0" anchor="ctr"/>
+          <a:lstStyle/>
+          <a:p>
+            <a:pPr algn="ctr"/>
+          </a:p>
+        </p:txBody>
+      </p:sp>
+      <p:sp>
+        <p:nvSpPr>
+          <p:cNvPr id="20" name="TextBox 19"/>
+          <p:cNvSpPr txBox="1"/>
+          <p:nvPr/>
+        </p:nvSpPr>
+        <p:spPr>
+          <a:xfrm>
+            <a:off x="8092440" y="2276856"/>
+            <a:ext cx="3566160" cy="365760"/>
+          </a:xfrm>
+          <a:prstGeom prst="rect">
+            <a:avLst/>
+          </a:prstGeom>
+          <a:noFill/>
+        </p:spPr>
+        <p:txBody>
+          <a:bodyPr wrap="none">
+            <a:spAutoFit/>
+          </a:bodyPr>
+          <a:lstStyle/>
+          <a:p>
+            <a:pPr algn="ctr">
+              <a:defRPr sz="1800" b="1">
+                <a:solidFill>
+                  <a:srgbClr val="0F3D6E"/>
+                </a:solidFill>
+                <a:latin typeface="Segoe UI"/>
+              </a:defRPr>
+            </a:pPr>
+            <a:r>
+              <a:t>1.00 </a:t>
+            </a:r>
+          </a:p>
+        </p:txBody>
+      </p:sp>
+      <p:sp>
+        <p:nvSpPr>
+          <p:cNvPr id="21" name="Rectangle 20"/>
+          <p:cNvSpPr/>
+          <p:nvPr/>
+        </p:nvSpPr>
+        <p:spPr>
+          <a:xfrm>
+            <a:off x="4160520" y="2514600"/>
+            <a:ext cx="7498079" cy="502920"/>
+          </a:xfrm>
+          <a:prstGeom prst="rect">
+            <a:avLst/>
+          </a:prstGeom>
+          <a:solidFill>
+            <a:srgbClr val="F1F5F9"/>
+          </a:solidFill>
+          <a:ln w="9525">
+            <a:solidFill>
+              <a:srgbClr val="E2E8EF"/>
+            </a:solidFill>
+          </a:ln>
+        </p:spPr>
+        <p:style>
+          <a:lnRef idx="1">
+            <a:schemeClr val="accent1"/>
+          </a:lnRef>
+          <a:fillRef idx="3">
+            <a:schemeClr val="accent1"/>
+          </a:fillRef>
+          <a:effectRef idx="2">
+            <a:schemeClr val="accent1"/>
+          </a:effectRef>
+          <a:fontRef idx="minor">
+            <a:schemeClr val="lt1"/>
+          </a:fontRef>
+        </p:style>
+        <p:txBody>
+          <a:bodyPr rtlCol="0" anchor="ctr" wrap="square" lIns="127000" tIns="76200" rIns="127000"/>
+          <a:lstStyle/>
+          <a:p>
+            <a:pPr algn="ctr">
+              <a:defRPr sz="950">
+                <a:solidFill>
+                  <a:srgbClr val="334155"/>
+                </a:solidFill>
+                <a:latin typeface="Segoe UI"/>
+              </a:defRPr>
+            </a:pPr>
+            <a:r>
+              <a:t>Bullet-graph reading: the triangle marker shows this period's actual value against green/amber/red performance zones — a faster read than a plain number for a board-level audience.</a:t>
+            </a:r>
+          </a:p>
+        </p:txBody>
+      </p:sp>
+      <p:sp>
+        <p:nvSpPr>
+          <p:cNvPr id="22" name="TextBox 21"/>
+          <p:cNvSpPr txBox="1"/>
+          <p:nvPr/>
+        </p:nvSpPr>
+        <p:spPr>
+          <a:xfrm>
+            <a:off x="457200" y="3383280"/>
+            <a:ext cx="7315200" cy="292608"/>
+          </a:xfrm>
+          <a:prstGeom prst="rect">
+            <a:avLst/>
+          </a:prstGeom>
+          <a:noFill/>
+        </p:spPr>
+        <p:txBody>
+          <a:bodyPr wrap="none">
+            <a:spAutoFit/>
+          </a:bodyPr>
+          <a:lstStyle/>
+          <a:p>
+            <a:pPr>
+              <a:defRPr sz="1300" b="1">
+                <a:solidFill>
+                  <a:srgbClr val="0F3D6E"/>
+                </a:solidFill>
+                <a:latin typeface="Segoe UI"/>
+              </a:defRPr>
+            </a:pPr>
+            <a:r>
+              <a:t>INCIDENT RISK RATING × DEPARTMENT  (real data, 12-month)</a:t>
+            </a:r>
+          </a:p>
+        </p:txBody>
+      </p:sp>
+      <p:sp>
+        <p:nvSpPr>
+          <p:cNvPr id="23" name="Rectangle 22"/>
+          <p:cNvSpPr/>
+          <p:nvPr/>
+        </p:nvSpPr>
+        <p:spPr>
+          <a:xfrm>
+            <a:off x="457200" y="3675888"/>
+            <a:ext cx="7315200" cy="25400"/>
+          </a:xfrm>
+          <a:prstGeom prst="rect">
+            <a:avLst/>
+          </a:prstGeom>
+          <a:solidFill>
+            <a:srgbClr val="0B6EA8"/>
+          </a:solidFill>
+          <a:ln>
+            <a:noFill/>
+          </a:ln>
+        </p:spPr>
+        <p:style>
+          <a:lnRef idx="1">
+            <a:schemeClr val="accent1"/>
+          </a:lnRef>
+          <a:fillRef idx="3">
+            <a:schemeClr val="accent1"/>
+          </a:fillRef>
+          <a:effectRef idx="2">
+            <a:schemeClr val="accent1"/>
+          </a:effectRef>
+          <a:fontRef idx="minor">
+            <a:schemeClr val="lt1"/>
+          </a:fontRef>
+        </p:style>
+        <p:txBody>
+          <a:bodyPr rtlCol="0" anchor="ctr"/>
+          <a:lstStyle/>
+          <a:p>
+            <a:pPr algn="ctr"/>
+          </a:p>
+        </p:txBody>
+      </p:sp>
+      <p:graphicFrame>
+        <p:nvGraphicFramePr>
+          <p:cNvPr id="24" name="Table 23"/>
+          <p:cNvGraphicFramePr>
+            <a:graphicFrameLocks noGrp="1"/>
+          </p:cNvGraphicFramePr>
+          <p:nvPr/>
+        </p:nvGraphicFramePr>
+        <p:xfrm>
+          <a:off x="457200" y="3794760"/>
+          <a:ext cx="7498079" cy="2377440"/>
+        </p:xfrm>
+        <a:graphic>
+          <a:graphicData uri="http://schemas.openxmlformats.org/drawingml/2006/table">
+            <a:tbl>
+              <a:tblPr firstRow="1" bandRow="1">
+                <a:tableStyleId>{5C22544A-7EE6-4342-B048-85BDC9FD1C3A}</a:tableStyleId>
+              </a:tblPr>
+              <a:tblGrid>
+                <a:gridCol w="1071154"/>
+                <a:gridCol w="1071154"/>
+                <a:gridCol w="1071154"/>
+                <a:gridCol w="1071154"/>
+                <a:gridCol w="1071154"/>
+                <a:gridCol w="1071154"/>
+                <a:gridCol w="1071155"/>
+              </a:tblGrid>
+              <a:tr h="475488">
+                <a:tc>
+                  <a:txBody>
+                    <a:bodyPr/>
+                    <a:lstStyle/>
+                    <a:p>
+                      <a:pPr>
+                        <a:defRPr b="1" sz="1000">
+                          <a:solidFill>
+                            <a:srgbClr val="FFFFFF"/>
+                          </a:solidFill>
+                          <a:latin typeface="Segoe UI"/>
+                        </a:defRPr>
+                      </a:pPr>
+                      <a:r>
+                        <a:t>Risk \ Dept</a:t>
+                      </a:r>
+                    </a:p>
+                  </a:txBody>
+                  <a:tcPr>
+                    <a:solidFill>
+                      <a:srgbClr val="0F3D6E"/>
+                    </a:solidFill>
+                  </a:tcPr>
+                </a:tc>
+                <a:tc>
+                  <a:txBody>
+                    <a:bodyPr/>
+                    <a:lstStyle/>
+                    <a:p>
+                      <a:pPr>
+                        <a:defRPr b="1" sz="1000">
+                          <a:solidFill>
+                            <a:srgbClr val="FFFFFF"/>
+                          </a:solidFill>
+                          <a:latin typeface="Segoe UI"/>
+                        </a:defRPr>
+                      </a:pPr>
+                      <a:r>
+                        <a:t>Admin</a:t>
+                      </a:r>
+                    </a:p>
+                  </a:txBody>
+                  <a:tcPr>
+                    <a:solidFill>
+                      <a:srgbClr val="0F3D6E"/>
+                    </a:solidFill>
+                  </a:tcPr>
+                </a:tc>
+                <a:tc>
+                  <a:txBody>
+                    <a:bodyPr/>
+                    <a:lstStyle/>
+                    <a:p>
+                      <a:pPr>
+                        <a:defRPr b="1" sz="1000">
+                          <a:solidFill>
+                            <a:srgbClr val="FFFFFF"/>
+                          </a:solidFill>
+                          <a:latin typeface="Segoe UI"/>
+                        </a:defRPr>
+                      </a:pPr>
+                      <a:r>
+                        <a:t>Constructi</a:t>
+                      </a:r>
+                    </a:p>
+                  </a:txBody>
+                  <a:tcPr>
+                    <a:solidFill>
+                      <a:srgbClr val="0F3D6E"/>
+                    </a:solidFill>
+                  </a:tcPr>
+                </a:tc>
+                <a:tc>
+                  <a:txBody>
+                    <a:bodyPr/>
+                    <a:lstStyle/>
+                    <a:p>
+                      <a:pPr>
+                        <a:defRPr b="1" sz="1000">
+                          <a:solidFill>
+                            <a:srgbClr val="FFFFFF"/>
+                          </a:solidFill>
+                          <a:latin typeface="Segoe UI"/>
+                        </a:defRPr>
+                      </a:pPr>
+                      <a:r>
+                        <a:t>Contractor</a:t>
+                      </a:r>
+                    </a:p>
+                  </a:txBody>
+                  <a:tcPr>
+                    <a:solidFill>
+                      <a:srgbClr val="0F3D6E"/>
+                    </a:solidFill>
+                  </a:tcPr>
+                </a:tc>
+                <a:tc>
+                  <a:txBody>
+                    <a:bodyPr/>
+                    <a:lstStyle/>
+                    <a:p>
+                      <a:pPr>
+                        <a:defRPr b="1" sz="1000">
+                          <a:solidFill>
+                            <a:srgbClr val="FFFFFF"/>
+                          </a:solidFill>
+                          <a:latin typeface="Segoe UI"/>
+                        </a:defRPr>
+                      </a:pPr>
+                      <a:r>
+                        <a:t>Engineerin</a:t>
+                      </a:r>
+                    </a:p>
+                  </a:txBody>
+                  <a:tcPr>
+                    <a:solidFill>
+                      <a:srgbClr val="0F3D6E"/>
+                    </a:solidFill>
+                  </a:tcPr>
+                </a:tc>
+                <a:tc>
+                  <a:txBody>
+                    <a:bodyPr/>
+                    <a:lstStyle/>
+                    <a:p>
+                      <a:pPr>
+                        <a:defRPr b="1" sz="1000">
+                          <a:solidFill>
+                            <a:srgbClr val="FFFFFF"/>
+                          </a:solidFill>
+                          <a:latin typeface="Segoe UI"/>
+                        </a:defRPr>
+                      </a:pPr>
+                      <a:r>
+                        <a:t>Logistics</a:t>
+                      </a:r>
+                    </a:p>
+                  </a:txBody>
+                  <a:tcPr>
+                    <a:solidFill>
+                      <a:srgbClr val="0F3D6E"/>
+                    </a:solidFill>
+                  </a:tcPr>
+                </a:tc>
+                <a:tc>
+                  <a:txBody>
+                    <a:bodyPr/>
+                    <a:lstStyle/>
+                    <a:p>
+                      <a:pPr>
+                        <a:defRPr b="1" sz="1000">
+                          <a:solidFill>
+                            <a:srgbClr val="FFFFFF"/>
+                          </a:solidFill>
+                          <a:latin typeface="Segoe UI"/>
+                        </a:defRPr>
+                      </a:pPr>
+                      <a:r>
+                        <a:t>Maintenanc</a:t>
+                      </a:r>
+                    </a:p>
+                  </a:txBody>
+                  <a:tcPr>
+                    <a:solidFill>
+                      <a:srgbClr val="0F3D6E"/>
+                    </a:solidFill>
+                  </a:tcPr>
+                </a:tc>
+              </a:tr>
+              <a:tr h="475488">
+                <a:tc>
+                  <a:txBody>
+                    <a:bodyPr/>
+                    <a:lstStyle/>
+                    <a:p>
+                      <a:pPr>
+                        <a:defRPr b="1" sz="1000">
+                          <a:solidFill>
+                            <a:srgbClr val="FFFFFF"/>
+                          </a:solidFill>
+                          <a:latin typeface="Segoe UI"/>
+                        </a:defRPr>
+                      </a:pPr>
+                      <a:r>
+                        <a:t>Critical</a:t>
+                      </a:r>
+                    </a:p>
+                  </a:txBody>
+                  <a:tcPr>
+                    <a:solidFill>
+                      <a:srgbClr val="334155"/>
+                    </a:solidFill>
+                  </a:tcPr>
+                </a:tc>
+                <a:tc>
+                  <a:txBody>
+                    <a:bodyPr/>
+                    <a:lstStyle/>
+                    <a:p>
+                      <a:pPr algn="ctr">
+                        <a:defRPr sz="1200" b="1">
+                          <a:solidFill>
+                            <a:srgbClr val="334155"/>
+                          </a:solidFill>
+                          <a:latin typeface="Segoe UI"/>
+                        </a:defRPr>
+                      </a:pPr>
+                      <a:r>
+                        <a:t>0</a:t>
+                      </a:r>
+                    </a:p>
+                  </a:txBody>
+                  <a:tcPr>
+                    <a:solidFill>
+                      <a:srgbClr val="FFFFFF"/>
+                    </a:solidFill>
+                  </a:tcPr>
+                </a:tc>
+                <a:tc>
+                  <a:txBody>
+                    <a:bodyPr/>
+                    <a:lstStyle/>
+                    <a:p>
+                      <a:pPr algn="ctr">
+                        <a:defRPr sz="1200" b="1">
+                          <a:solidFill>
+                            <a:srgbClr val="334155"/>
+                          </a:solidFill>
+                          <a:latin typeface="Segoe UI"/>
+                        </a:defRPr>
+                      </a:pPr>
+                      <a:r>
+                        <a:t>0</a:t>
+                      </a:r>
+                    </a:p>
+                  </a:txBody>
+                  <a:tcPr>
+                    <a:solidFill>
+                      <a:srgbClr val="FFFFFF"/>
+                    </a:solidFill>
+                  </a:tcPr>
+                </a:tc>
+                <a:tc>
+                  <a:txBody>
+                    <a:bodyPr/>
+                    <a:lstStyle/>
+                    <a:p>
+                      <a:pPr algn="ctr">
+                        <a:defRPr sz="1200" b="1">
+                          <a:solidFill>
+                            <a:srgbClr val="334155"/>
+                          </a:solidFill>
+                          <a:latin typeface="Segoe UI"/>
+                        </a:defRPr>
+                      </a:pPr>
+                      <a:r>
+                        <a:t>1</a:t>
+                      </a:r>
+                    </a:p>
+                  </a:txBody>
+                  <a:tcPr>
+                    <a:solidFill>
+                      <a:srgbClr val="FEF3C7"/>
+                    </a:solidFill>
+                  </a:tcPr>
+                </a:tc>
+                <a:tc>
+                  <a:txBody>
+                    <a:bodyPr/>
+                    <a:lstStyle/>
+                    <a:p>
+                      <a:pPr algn="ctr">
+                        <a:defRPr sz="1200" b="1">
+                          <a:solidFill>
+                            <a:srgbClr val="334155"/>
+                          </a:solidFill>
+                          <a:latin typeface="Segoe UI"/>
+                        </a:defRPr>
+                      </a:pPr>
+                      <a:r>
+                        <a:t>0</a:t>
+                      </a:r>
+                    </a:p>
+                  </a:txBody>
+                  <a:tcPr>
+                    <a:solidFill>
+                      <a:srgbClr val="FFFFFF"/>
+                    </a:solidFill>
+                  </a:tcPr>
+                </a:tc>
+                <a:tc>
+                  <a:txBody>
+                    <a:bodyPr/>
+                    <a:lstStyle/>
+                    <a:p>
+                      <a:pPr algn="ctr">
+                        <a:defRPr sz="1200" b="1">
+                          <a:solidFill>
+                            <a:srgbClr val="334155"/>
+                          </a:solidFill>
+                          <a:latin typeface="Segoe UI"/>
+                        </a:defRPr>
+                      </a:pPr>
+                      <a:r>
+                        <a:t>1</a:t>
+                      </a:r>
+                    </a:p>
+                  </a:txBody>
+                  <a:tcPr>
+                    <a:solidFill>
+                      <a:srgbClr val="FEF3C7"/>
+                    </a:solidFill>
+                  </a:tcPr>
+                </a:tc>
+                <a:tc>
+                  <a:txBody>
+                    <a:bodyPr/>
+                    <a:lstStyle/>
+                    <a:p>
+                      <a:pPr algn="ctr">
+                        <a:defRPr sz="1200" b="1">
+                          <a:solidFill>
+                            <a:srgbClr val="334155"/>
+                          </a:solidFill>
+                          <a:latin typeface="Segoe UI"/>
+                        </a:defRPr>
+                      </a:pPr>
+                      <a:r>
+                        <a:t>0</a:t>
+                      </a:r>
+                    </a:p>
+                  </a:txBody>
+                  <a:tcPr>
+                    <a:solidFill>
+                      <a:srgbClr val="FFFFFF"/>
+                    </a:solidFill>
+                  </a:tcPr>
+                </a:tc>
+              </a:tr>
+              <a:tr h="475488">
+                <a:tc>
+                  <a:txBody>
+                    <a:bodyPr/>
+                    <a:lstStyle/>
+                    <a:p>
+                      <a:pPr>
+                        <a:defRPr b="1" sz="1000">
+                          <a:solidFill>
+                            <a:srgbClr val="FFFFFF"/>
+                          </a:solidFill>
+                          <a:latin typeface="Segoe UI"/>
+                        </a:defRPr>
+                      </a:pPr>
+                      <a:r>
+                        <a:t>High</a:t>
+                      </a:r>
+                    </a:p>
+                  </a:txBody>
+                  <a:tcPr>
+                    <a:solidFill>
+                      <a:srgbClr val="334155"/>
+                    </a:solidFill>
+                  </a:tcPr>
+                </a:tc>
+                <a:tc>
+                  <a:txBody>
+                    <a:bodyPr/>
+                    <a:lstStyle/>
+                    <a:p>
+                      <a:pPr algn="ctr">
+                        <a:defRPr sz="1200" b="1">
+                          <a:solidFill>
+                            <a:srgbClr val="334155"/>
+                          </a:solidFill>
+                          <a:latin typeface="Segoe UI"/>
+                        </a:defRPr>
+                      </a:pPr>
+                      <a:r>
+                        <a:t>1</a:t>
+                      </a:r>
+                    </a:p>
+                  </a:txBody>
+                  <a:tcPr>
+                    <a:solidFill>
+                      <a:srgbClr val="FEF3C7"/>
+                    </a:solidFill>
+                  </a:tcPr>
+                </a:tc>
+                <a:tc>
+                  <a:txBody>
+                    <a:bodyPr/>
+                    <a:lstStyle/>
+                    <a:p>
+                      <a:pPr algn="ctr">
+                        <a:defRPr sz="1200" b="1">
+                          <a:solidFill>
+                            <a:srgbClr val="334155"/>
+                          </a:solidFill>
+                          <a:latin typeface="Segoe UI"/>
+                        </a:defRPr>
+                      </a:pPr>
+                      <a:r>
+                        <a:t>0</a:t>
+                      </a:r>
+                    </a:p>
+                  </a:txBody>
+                  <a:tcPr>
+                    <a:solidFill>
+                      <a:srgbClr val="FFFFFF"/>
+                    </a:solidFill>
+                  </a:tcPr>
+                </a:tc>
+                <a:tc>
+                  <a:txBody>
+                    <a:bodyPr/>
+                    <a:lstStyle/>
+                    <a:p>
+                      <a:pPr algn="ctr">
+                        <a:defRPr sz="1200" b="1">
+                          <a:solidFill>
+                            <a:srgbClr val="334155"/>
+                          </a:solidFill>
+                          <a:latin typeface="Segoe UI"/>
+                        </a:defRPr>
+                      </a:pPr>
+                      <a:r>
+                        <a:t>2</a:t>
+                      </a:r>
+                    </a:p>
+                  </a:txBody>
+                  <a:tcPr>
+                    <a:solidFill>
+                      <a:srgbClr val="FCD34D"/>
+                    </a:solidFill>
+                  </a:tcPr>
+                </a:tc>
+                <a:tc>
+                  <a:txBody>
+                    <a:bodyPr/>
+                    <a:lstStyle/>
+                    <a:p>
+                      <a:pPr algn="ctr">
+                        <a:defRPr sz="1200" b="1">
+                          <a:solidFill>
+                            <a:srgbClr val="334155"/>
+                          </a:solidFill>
+                          <a:latin typeface="Segoe UI"/>
+                        </a:defRPr>
+                      </a:pPr>
+                      <a:r>
+                        <a:t>0</a:t>
+                      </a:r>
+                    </a:p>
+                  </a:txBody>
+                  <a:tcPr>
+                    <a:solidFill>
+                      <a:srgbClr val="FFFFFF"/>
+                    </a:solidFill>
+                  </a:tcPr>
+                </a:tc>
+                <a:tc>
+                  <a:txBody>
+                    <a:bodyPr/>
+                    <a:lstStyle/>
+                    <a:p>
+                      <a:pPr algn="ctr">
+                        <a:defRPr sz="1200" b="1">
+                          <a:solidFill>
+                            <a:srgbClr val="334155"/>
+                          </a:solidFill>
+                          <a:latin typeface="Segoe UI"/>
+                        </a:defRPr>
+                      </a:pPr>
+                      <a:r>
+                        <a:t>0</a:t>
+                      </a:r>
+                    </a:p>
+                  </a:txBody>
+                  <a:tcPr>
+                    <a:solidFill>
+                      <a:srgbClr val="FFFFFF"/>
+                    </a:solidFill>
+                  </a:tcPr>
+                </a:tc>
+                <a:tc>
+                  <a:txBody>
+                    <a:bodyPr/>
+                    <a:lstStyle/>
+                    <a:p>
+                      <a:pPr algn="ctr">
+                        <a:defRPr sz="1200" b="1">
+                          <a:solidFill>
+                            <a:srgbClr val="334155"/>
+                          </a:solidFill>
+                          <a:latin typeface="Segoe UI"/>
+                        </a:defRPr>
+                      </a:pPr>
+                      <a:r>
+                        <a:t>2</a:t>
+                      </a:r>
+                    </a:p>
+                  </a:txBody>
+                  <a:tcPr>
+                    <a:solidFill>
+                      <a:srgbClr val="FCD34D"/>
+                    </a:solidFill>
+                  </a:tcPr>
+                </a:tc>
+              </a:tr>
+              <a:tr h="475488">
+                <a:tc>
+                  <a:txBody>
+                    <a:bodyPr/>
+                    <a:lstStyle/>
+                    <a:p>
+                      <a:pPr>
+                        <a:defRPr b="1" sz="1000">
+                          <a:solidFill>
+                            <a:srgbClr val="FFFFFF"/>
+                          </a:solidFill>
+                          <a:latin typeface="Segoe UI"/>
+                        </a:defRPr>
+                      </a:pPr>
+                      <a:r>
+                        <a:t>Medium</a:t>
+                      </a:r>
+                    </a:p>
+                  </a:txBody>
+                  <a:tcPr>
+                    <a:solidFill>
+                      <a:srgbClr val="334155"/>
+                    </a:solidFill>
+                  </a:tcPr>
+                </a:tc>
+                <a:tc>
+                  <a:txBody>
+                    <a:bodyPr/>
+                    <a:lstStyle/>
+                    <a:p>
+                      <a:pPr algn="ctr">
+                        <a:defRPr sz="1200" b="1">
+                          <a:solidFill>
+                            <a:srgbClr val="334155"/>
+                          </a:solidFill>
+                          <a:latin typeface="Segoe UI"/>
+                        </a:defRPr>
+                      </a:pPr>
+                      <a:r>
+                        <a:t>1</a:t>
+                      </a:r>
+                    </a:p>
+                  </a:txBody>
+                  <a:tcPr>
+                    <a:solidFill>
+                      <a:srgbClr val="FEF3C7"/>
+                    </a:solidFill>
+                  </a:tcPr>
+                </a:tc>
+                <a:tc>
+                  <a:txBody>
+                    <a:bodyPr/>
+                    <a:lstStyle/>
+                    <a:p>
+                      <a:pPr algn="ctr">
+                        <a:defRPr sz="1200" b="1">
+                          <a:solidFill>
+                            <a:srgbClr val="FFFFFF"/>
+                          </a:solidFill>
+                          <a:latin typeface="Segoe UI"/>
+                        </a:defRPr>
+                      </a:pPr>
+                      <a:r>
+                        <a:t>5</a:t>
+                      </a:r>
+                    </a:p>
+                  </a:txBody>
+                  <a:tcPr>
+                    <a:solidFill>
+                      <a:srgbClr val="DC2626"/>
+                    </a:solidFill>
+                  </a:tcPr>
+                </a:tc>
+                <a:tc>
+                  <a:txBody>
+                    <a:bodyPr/>
+                    <a:lstStyle/>
+                    <a:p>
+                      <a:pPr algn="ctr">
+                        <a:defRPr sz="1200" b="1">
+                          <a:solidFill>
+                            <a:srgbClr val="334155"/>
+                          </a:solidFill>
+                          <a:latin typeface="Segoe UI"/>
+                        </a:defRPr>
+                      </a:pPr>
+                      <a:r>
+                        <a:t>0</a:t>
+                      </a:r>
+                    </a:p>
+                  </a:txBody>
+                  <a:tcPr>
+                    <a:solidFill>
+                      <a:srgbClr val="FFFFFF"/>
+                    </a:solidFill>
+                  </a:tcPr>
+                </a:tc>
+                <a:tc>
+                  <a:txBody>
+                    <a:bodyPr/>
+                    <a:lstStyle/>
+                    <a:p>
+                      <a:pPr algn="ctr">
+                        <a:defRPr sz="1200" b="1">
+                          <a:solidFill>
+                            <a:srgbClr val="334155"/>
+                          </a:solidFill>
+                          <a:latin typeface="Segoe UI"/>
+                        </a:defRPr>
+                      </a:pPr>
+                      <a:r>
+                        <a:t>1</a:t>
+                      </a:r>
+                    </a:p>
+                  </a:txBody>
+                  <a:tcPr>
+                    <a:solidFill>
+                      <a:srgbClr val="FEF3C7"/>
+                    </a:solidFill>
+                  </a:tcPr>
+                </a:tc>
+                <a:tc>
+                  <a:txBody>
+                    <a:bodyPr/>
+                    <a:lstStyle/>
+                    <a:p>
+                      <a:pPr algn="ctr">
+                        <a:defRPr sz="1200" b="1">
+                          <a:solidFill>
+                            <a:srgbClr val="FFFFFF"/>
+                          </a:solidFill>
+                          <a:latin typeface="Segoe UI"/>
+                        </a:defRPr>
+                      </a:pPr>
+                      <a:r>
+                        <a:t>4</a:t>
+                      </a:r>
+                    </a:p>
+                  </a:txBody>
+                  <a:tcPr>
+                    <a:solidFill>
+                      <a:srgbClr val="DC2626"/>
+                    </a:solidFill>
+                  </a:tcPr>
+                </a:tc>
+                <a:tc>
+                  <a:txBody>
+                    <a:bodyPr/>
+                    <a:lstStyle/>
+                    <a:p>
+                      <a:pPr algn="ctr">
+                        <a:defRPr sz="1200" b="1">
+                          <a:solidFill>
+                            <a:srgbClr val="334155"/>
+                          </a:solidFill>
+                          <a:latin typeface="Segoe UI"/>
+                        </a:defRPr>
+                      </a:pPr>
+                      <a:r>
+                        <a:t>2</a:t>
+                      </a:r>
+                    </a:p>
+                  </a:txBody>
+                  <a:tcPr>
+                    <a:solidFill>
+                      <a:srgbClr val="FCD34D"/>
+                    </a:solidFill>
+                  </a:tcPr>
+                </a:tc>
+              </a:tr>
+              <a:tr h="475488">
+                <a:tc>
+                  <a:txBody>
+                    <a:bodyPr/>
+                    <a:lstStyle/>
+                    <a:p>
+                      <a:pPr>
+                        <a:defRPr b="1" sz="1000">
+                          <a:solidFill>
+                            <a:srgbClr val="FFFFFF"/>
+                          </a:solidFill>
+                          <a:latin typeface="Segoe UI"/>
+                        </a:defRPr>
+                      </a:pPr>
+                      <a:r>
+                        <a:t>Low</a:t>
+                      </a:r>
+                    </a:p>
+                  </a:txBody>
+                  <a:tcPr>
+                    <a:solidFill>
+                      <a:srgbClr val="334155"/>
+                    </a:solidFill>
+                  </a:tcPr>
+                </a:tc>
+                <a:tc>
+                  <a:txBody>
+                    <a:bodyPr/>
+                    <a:lstStyle/>
+                    <a:p>
+                      <a:pPr algn="ctr">
+                        <a:defRPr sz="1200" b="1">
+                          <a:solidFill>
+                            <a:srgbClr val="334155"/>
+                          </a:solidFill>
+                          <a:latin typeface="Segoe UI"/>
+                        </a:defRPr>
+                      </a:pPr>
+                      <a:r>
+                        <a:t>2</a:t>
+                      </a:r>
+                    </a:p>
+                  </a:txBody>
+                  <a:tcPr>
+                    <a:solidFill>
+                      <a:srgbClr val="FCD34D"/>
+                    </a:solidFill>
+                  </a:tcPr>
+                </a:tc>
+                <a:tc>
+                  <a:txBody>
+                    <a:bodyPr/>
+                    <a:lstStyle/>
+                    <a:p>
+                      <a:pPr algn="ctr">
+                        <a:defRPr sz="1200" b="1">
+                          <a:solidFill>
+                            <a:srgbClr val="334155"/>
+                          </a:solidFill>
+                          <a:latin typeface="Segoe UI"/>
+                        </a:defRPr>
+                      </a:pPr>
+                      <a:r>
+                        <a:t>2</a:t>
+                      </a:r>
+                    </a:p>
+                  </a:txBody>
+                  <a:tcPr>
+                    <a:solidFill>
+                      <a:srgbClr val="FCD34D"/>
+                    </a:solidFill>
+                  </a:tcPr>
+                </a:tc>
+                <a:tc>
+                  <a:txBody>
+                    <a:bodyPr/>
+                    <a:lstStyle/>
+                    <a:p>
+                      <a:pPr algn="ctr">
+                        <a:defRPr sz="1200" b="1">
+                          <a:solidFill>
+                            <a:srgbClr val="334155"/>
+                          </a:solidFill>
+                          <a:latin typeface="Segoe UI"/>
+                        </a:defRPr>
+                      </a:pPr>
+                      <a:r>
+                        <a:t>2</a:t>
+                      </a:r>
+                    </a:p>
+                  </a:txBody>
+                  <a:tcPr>
+                    <a:solidFill>
+                      <a:srgbClr val="FCD34D"/>
+                    </a:solidFill>
+                  </a:tcPr>
+                </a:tc>
+                <a:tc>
+                  <a:txBody>
+                    <a:bodyPr/>
+                    <a:lstStyle/>
+                    <a:p>
+                      <a:pPr algn="ctr">
+                        <a:defRPr sz="1200" b="1">
+                          <a:solidFill>
+                            <a:srgbClr val="334155"/>
+                          </a:solidFill>
+                          <a:latin typeface="Segoe UI"/>
+                        </a:defRPr>
+                      </a:pPr>
+                      <a:r>
+                        <a:t>2</a:t>
+                      </a:r>
+                    </a:p>
+                  </a:txBody>
+                  <a:tcPr>
+                    <a:solidFill>
+                      <a:srgbClr val="FCD34D"/>
+                    </a:solidFill>
+                  </a:tcPr>
+                </a:tc>
+                <a:tc>
+                  <a:txBody>
+                    <a:bodyPr/>
+                    <a:lstStyle/>
+                    <a:p>
+                      <a:pPr algn="ctr">
+                        <a:defRPr sz="1200" b="1">
+                          <a:solidFill>
+                            <a:srgbClr val="334155"/>
+                          </a:solidFill>
+                          <a:latin typeface="Segoe UI"/>
+                        </a:defRPr>
+                      </a:pPr>
+                      <a:r>
+                        <a:t>1</a:t>
+                      </a:r>
+                    </a:p>
+                  </a:txBody>
+                  <a:tcPr>
+                    <a:solidFill>
+                      <a:srgbClr val="FEF3C7"/>
+                    </a:solidFill>
+                  </a:tcPr>
+                </a:tc>
+                <a:tc>
+                  <a:txBody>
+                    <a:bodyPr/>
+                    <a:lstStyle/>
+                    <a:p>
+                      <a:pPr algn="ctr">
+                        <a:defRPr sz="1200" b="1">
+                          <a:solidFill>
+                            <a:srgbClr val="334155"/>
+                          </a:solidFill>
+                          <a:latin typeface="Segoe UI"/>
+                        </a:defRPr>
+                      </a:pPr>
+                      <a:r>
+                        <a:t>2</a:t>
+                      </a:r>
+                    </a:p>
+                  </a:txBody>
+                  <a:tcPr>
+                    <a:solidFill>
+                      <a:srgbClr val="FCD34D"/>
+                    </a:solidFill>
+                  </a:tcPr>
+                </a:tc>
+              </a:tr>
+            </a:tbl>
+          </a:graphicData>
+        </a:graphic>
+      </p:graphicFrame>
+      <p:sp>
+        <p:nvSpPr>
+          <p:cNvPr id="25" name="Rectangle 24"/>
+          <p:cNvSpPr/>
+          <p:nvPr/>
+        </p:nvSpPr>
+        <p:spPr>
+          <a:xfrm>
+            <a:off x="8229600" y="3794760"/>
+            <a:ext cx="3429000" cy="2377440"/>
+          </a:xfrm>
+          <a:prstGeom prst="rect">
+            <a:avLst/>
+          </a:prstGeom>
+          <a:solidFill>
+            <a:srgbClr val="F1F5F9"/>
+          </a:solidFill>
+          <a:ln w="9525">
+            <a:solidFill>
+              <a:srgbClr val="E2E8EF"/>
+            </a:solidFill>
+          </a:ln>
+        </p:spPr>
+        <p:style>
+          <a:lnRef idx="1">
+            <a:schemeClr val="accent1"/>
+          </a:lnRef>
+          <a:fillRef idx="3">
+            <a:schemeClr val="accent1"/>
+          </a:fillRef>
+          <a:effectRef idx="2">
+            <a:schemeClr val="accent1"/>
+          </a:effectRef>
+          <a:fontRef idx="minor">
+            <a:schemeClr val="lt1"/>
+          </a:fontRef>
+        </p:style>
+        <p:txBody>
+          <a:bodyPr rtlCol="0" anchor="ctr" wrap="square" lIns="127000" tIns="76200" rIns="127000"/>
+          <a:lstStyle/>
+          <a:p>
+            <a:pPr algn="ctr">
+              <a:defRPr sz="950">
+                <a:solidFill>
+                  <a:srgbClr val="334155"/>
+                </a:solidFill>
+                <a:latin typeface="Segoe UI"/>
+              </a:defRPr>
+            </a:pPr>
+            <a:r>
+              <a:t>Darker red = more incidents at that Risk Rating × Department intersection. This is the same cross-tab as the Excel workbook's Risk Heat Map, redrawn as a boardroom-ready table — every cell is directly editable (click once, type a new number).</a:t>
+            </a:r>
+          </a:p>
+        </p:txBody>
+      </p:sp>
+    </p:spTree>
+  </p:cSld>
+  <p:clrMapOvr>
+    <a:masterClrMapping/>
+  </p:clrMapOvr>
+</p:sld>
+</file>
+
+<file path=ppt/slides/slide8.xml><?xml version="1.0" encoding="utf-8"?>
+<p:sld xmlns:a="http://schemas.openxmlformats.org/drawingml/2006/main" xmlns:p="http://schemas.openxmlformats.org/presentationml/2006/main" xmlns:r="http://schemas.openxmlformats.org/officeDocument/2006/relationships">
+  <p:cSld>
+    <p:spTree>
+      <p:nvGrpSpPr>
+        <p:cNvPr id="1" name=""/>
+        <p:cNvGrpSpPr/>
+        <p:nvPr/>
+      </p:nvGrpSpPr>
+      <p:grpSpPr/>
+      <p:sp>
+        <p:nvSpPr>
+          <p:cNvPr id="2" name="Rectangle 1"/>
+          <p:cNvSpPr/>
+          <p:nvPr/>
+        </p:nvSpPr>
+        <p:spPr>
+          <a:xfrm>
+            <a:off x="0" y="0"/>
+            <a:ext cx="12191695" cy="960120"/>
+          </a:xfrm>
+          <a:prstGeom prst="rect">
+            <a:avLst/>
+          </a:prstGeom>
+          <a:solidFill>
+            <a:srgbClr val="0F3D6E"/>
+          </a:solidFill>
+          <a:ln>
+            <a:noFill/>
+          </a:ln>
+        </p:spPr>
+        <p:style>
+          <a:lnRef idx="1">
+            <a:schemeClr val="accent1"/>
+          </a:lnRef>
+          <a:fillRef idx="3">
+            <a:schemeClr val="accent1"/>
+          </a:fillRef>
+          <a:effectRef idx="2">
+            <a:schemeClr val="accent1"/>
+          </a:effectRef>
+          <a:fontRef idx="minor">
+            <a:schemeClr val="lt1"/>
+          </a:fontRef>
+        </p:style>
+        <p:txBody>
+          <a:bodyPr rtlCol="0" anchor="ctr"/>
+          <a:lstStyle/>
+          <a:p>
+            <a:pPr algn="ctr"/>
+          </a:p>
+        </p:txBody>
+      </p:sp>
+      <p:sp>
+        <p:nvSpPr>
+          <p:cNvPr id="3" name="TextBox 2"/>
+          <p:cNvSpPr txBox="1"/>
+          <p:nvPr/>
+        </p:nvSpPr>
+        <p:spPr>
+          <a:xfrm>
+            <a:off x="365760" y="109728"/>
+            <a:ext cx="9601200" cy="548640"/>
+          </a:xfrm>
+          <a:prstGeom prst="rect">
+            <a:avLst/>
+          </a:prstGeom>
+          <a:noFill/>
+        </p:spPr>
+        <p:txBody>
+          <a:bodyPr wrap="none">
+            <a:spAutoFit/>
+          </a:bodyPr>
+          <a:lstStyle/>
+          <a:p>
+            <a:pPr>
+              <a:defRPr sz="2600" b="1">
+                <a:solidFill>
+                  <a:srgbClr val="FFFFFF"/>
+                </a:solidFill>
+                <a:latin typeface="Segoe UI"/>
+              </a:defRPr>
+            </a:pPr>
+            <a:r>
               <a:t>🔎  KEY INSIGHTS FOR LEADERSHIP</a:t>
             </a:r>
           </a:p>
@@ -8761,7 +12585,7 @@
 </p:sld>
 </file>
 
-<file path=ppt/slides/slide7.xml><?xml version="1.0" encoding="utf-8"?>
+<file path=ppt/slides/slide9.xml><?xml version="1.0" encoding="utf-8"?>
 <p:sld xmlns:a="http://schemas.openxmlformats.org/drawingml/2006/main" xmlns:p="http://schemas.openxmlformats.org/presentationml/2006/main" xmlns:r="http://schemas.openxmlformats.org/officeDocument/2006/relationships">
   <p:cSld>
     <p:spTree>

</xml_diff>